<commit_message>
Added files for first half of Lab C
</commit_message>
<xml_diff>
--- a/docs/chapters/week3/images.pptx
+++ b/docs/chapters/week3/images.pptx
@@ -8,6 +8,11 @@
     <p:sldId id="256" r:id="rId2"/>
     <p:sldId id="257" r:id="rId3"/>
     <p:sldId id="258" r:id="rId4"/>
+    <p:sldId id="259" r:id="rId5"/>
+    <p:sldId id="260" r:id="rId6"/>
+    <p:sldId id="261" r:id="rId7"/>
+    <p:sldId id="262" r:id="rId8"/>
+    <p:sldId id="263" r:id="rId9"/>
   </p:sldIdLst>
   <p:sldSz cx="12192000" cy="6858000"/>
   <p:notesSz cx="6858000" cy="9144000"/>
@@ -106,13 +111,18 @@
       </a:defRPr>
     </a:lvl9pPr>
   </p:defaultTextStyle>
+  <p:extLst>
+    <p:ext uri="{EFAFB233-063F-42B5-8137-9DF3F51BA10A}">
+      <p15:sldGuideLst xmlns:p15="http://schemas.microsoft.com/office/powerpoint/2012/main"/>
+    </p:ext>
+  </p:extLst>
 </p:presentation>
 </file>
 
 <file path=ppt/revisionInfo.xml><?xml version="1.0" encoding="utf-8"?>
 <p1510:revInfo xmlns:a="http://schemas.openxmlformats.org/drawingml/2006/main" xmlns:r="http://schemas.openxmlformats.org/officeDocument/2006/relationships" xmlns:p1510="http://schemas.microsoft.com/office/powerpoint/2015/10/main">
   <p1510:revLst>
-    <p1510:client id="{2F1F597A-9983-4D95-8A05-48115C0ECFCB}" v="3" dt="2025-08-08T05:40:08.227"/>
+    <p1510:client id="{6754D92A-69B0-4ED5-949C-BCEED9E812F5}" v="5" dt="2025-11-18T20:57:16.118"/>
   </p1510:revLst>
 </p1510:revInfo>
 </file>
@@ -120,103 +130,260 @@
 <file path=ppt/changesInfos/changesInfo1.xml><?xml version="1.0" encoding="utf-8"?>
 <pc:chgInfo xmlns:a="http://schemas.openxmlformats.org/drawingml/2006/main" xmlns:r="http://schemas.openxmlformats.org/officeDocument/2006/relationships" xmlns:ac="http://schemas.microsoft.com/office/drawing/2013/main/command" xmlns:pc="http://schemas.microsoft.com/office/powerpoint/2013/main/command">
   <pc:docChgLst>
-    <pc:chgData name="Alex Casson" userId="53cffa54-f866-4b4c-8e51-0383f28edfe1" providerId="ADAL" clId="{2F1F597A-9983-4D95-8A05-48115C0ECFCB}"/>
-    <pc:docChg chg="undo custSel addSld modSld">
-      <pc:chgData name="Alex Casson" userId="53cffa54-f866-4b4c-8e51-0383f28edfe1" providerId="ADAL" clId="{2F1F597A-9983-4D95-8A05-48115C0ECFCB}" dt="2025-08-08T06:00:23.758" v="71" actId="22"/>
+    <pc:chgData name="Alex Casson" userId="53cffa54-f866-4b4c-8e51-0383f28edfe1" providerId="ADAL" clId="{6CFC2141-1B0A-45D5-9B60-96DCD45AC834}"/>
+    <pc:docChg chg="custSel addSld modSld sldOrd">
+      <pc:chgData name="Alex Casson" userId="53cffa54-f866-4b4c-8e51-0383f28edfe1" providerId="ADAL" clId="{6CFC2141-1B0A-45D5-9B60-96DCD45AC834}" dt="2025-11-18T20:57:16.118" v="136"/>
       <pc:docMkLst>
         <pc:docMk/>
       </pc:docMkLst>
-      <pc:sldChg chg="addSp delSp modSp new mod">
-        <pc:chgData name="Alex Casson" userId="53cffa54-f866-4b4c-8e51-0383f28edfe1" providerId="ADAL" clId="{2F1F597A-9983-4D95-8A05-48115C0ECFCB}" dt="2025-08-08T05:40:53.900" v="67" actId="208"/>
+      <pc:sldChg chg="addSp delSp modSp new mod ord">
+        <pc:chgData name="Alex Casson" userId="53cffa54-f866-4b4c-8e51-0383f28edfe1" providerId="ADAL" clId="{6CFC2141-1B0A-45D5-9B60-96DCD45AC834}" dt="2025-11-17T16:02:37.496" v="8" actId="14100"/>
         <pc:sldMkLst>
           <pc:docMk/>
-          <pc:sldMk cId="1081830049" sldId="257"/>
+          <pc:sldMk cId="2512259164" sldId="259"/>
         </pc:sldMkLst>
         <pc:spChg chg="del">
-          <ac:chgData name="Alex Casson" userId="53cffa54-f866-4b4c-8e51-0383f28edfe1" providerId="ADAL" clId="{2F1F597A-9983-4D95-8A05-48115C0ECFCB}" dt="2025-08-08T05:39:17.475" v="2" actId="478"/>
+          <ac:chgData name="Alex Casson" userId="53cffa54-f866-4b4c-8e51-0383f28edfe1" providerId="ADAL" clId="{6CFC2141-1B0A-45D5-9B60-96DCD45AC834}" dt="2025-11-17T16:02:17.178" v="2" actId="478"/>
           <ac:spMkLst>
             <pc:docMk/>
-            <pc:sldMk cId="1081830049" sldId="257"/>
-            <ac:spMk id="2" creationId="{E8E14ABD-4056-9B1C-1B2F-D1EAA58FF54B}"/>
+            <pc:sldMk cId="2512259164" sldId="259"/>
+            <ac:spMk id="2" creationId="{87797055-625E-2C6B-B869-D2D5E1B20525}"/>
           </ac:spMkLst>
         </pc:spChg>
         <pc:spChg chg="del">
-          <ac:chgData name="Alex Casson" userId="53cffa54-f866-4b4c-8e51-0383f28edfe1" providerId="ADAL" clId="{2F1F597A-9983-4D95-8A05-48115C0ECFCB}" dt="2025-08-08T05:39:16.825" v="1" actId="478"/>
+          <ac:chgData name="Alex Casson" userId="53cffa54-f866-4b4c-8e51-0383f28edfe1" providerId="ADAL" clId="{6CFC2141-1B0A-45D5-9B60-96DCD45AC834}" dt="2025-11-17T16:02:15.323" v="1" actId="478"/>
           <ac:spMkLst>
             <pc:docMk/>
-            <pc:sldMk cId="1081830049" sldId="257"/>
-            <ac:spMk id="3" creationId="{6920FCFB-27F3-8107-3D42-65A79E39CD51}"/>
+            <pc:sldMk cId="2512259164" sldId="259"/>
+            <ac:spMk id="3" creationId="{9AA3A382-A011-0A3A-A7A3-1C9CD34D13A8}"/>
           </ac:spMkLst>
         </pc:spChg>
         <pc:spChg chg="add mod">
-          <ac:chgData name="Alex Casson" userId="53cffa54-f866-4b4c-8e51-0383f28edfe1" providerId="ADAL" clId="{2F1F597A-9983-4D95-8A05-48115C0ECFCB}" dt="2025-08-08T05:39:38.598" v="6" actId="14100"/>
+          <ac:chgData name="Alex Casson" userId="53cffa54-f866-4b4c-8e51-0383f28edfe1" providerId="ADAL" clId="{6CFC2141-1B0A-45D5-9B60-96DCD45AC834}" dt="2025-11-17T16:02:37.496" v="8" actId="14100"/>
           <ac:spMkLst>
             <pc:docMk/>
-            <pc:sldMk cId="1081830049" sldId="257"/>
-            <ac:spMk id="6" creationId="{216A6903-969E-5EAD-F321-558D41B8FAFA}"/>
+            <pc:sldMk cId="2512259164" sldId="259"/>
+            <ac:spMk id="6" creationId="{320E8F30-1B8A-0B6C-9355-1BB1D837E895}"/>
+          </ac:spMkLst>
+        </pc:spChg>
+        <pc:picChg chg="add">
+          <ac:chgData name="Alex Casson" userId="53cffa54-f866-4b4c-8e51-0383f28edfe1" providerId="ADAL" clId="{6CFC2141-1B0A-45D5-9B60-96DCD45AC834}" dt="2025-11-17T16:02:17.950" v="3" actId="22"/>
+          <ac:picMkLst>
+            <pc:docMk/>
+            <pc:sldMk cId="2512259164" sldId="259"/>
+            <ac:picMk id="5" creationId="{33DD15CC-2043-EF58-D2C0-908A36FEB1E6}"/>
+          </ac:picMkLst>
+        </pc:picChg>
+      </pc:sldChg>
+      <pc:sldChg chg="addSp delSp modSp new mod">
+        <pc:chgData name="Alex Casson" userId="53cffa54-f866-4b4c-8e51-0383f28edfe1" providerId="ADAL" clId="{6CFC2141-1B0A-45D5-9B60-96DCD45AC834}" dt="2025-11-17T16:16:49.187" v="110" actId="14100"/>
+        <pc:sldMkLst>
+          <pc:docMk/>
+          <pc:sldMk cId="2342404083" sldId="260"/>
+        </pc:sldMkLst>
+        <pc:spChg chg="del">
+          <ac:chgData name="Alex Casson" userId="53cffa54-f866-4b4c-8e51-0383f28edfe1" providerId="ADAL" clId="{6CFC2141-1B0A-45D5-9B60-96DCD45AC834}" dt="2025-11-17T16:15:00.899" v="11" actId="478"/>
+          <ac:spMkLst>
+            <pc:docMk/>
+            <pc:sldMk cId="2342404083" sldId="260"/>
+            <ac:spMk id="2" creationId="{9D8A0B13-6971-DF51-BB40-B3552A1E9AA4}"/>
+          </ac:spMkLst>
+        </pc:spChg>
+        <pc:spChg chg="del">
+          <ac:chgData name="Alex Casson" userId="53cffa54-f866-4b4c-8e51-0383f28edfe1" providerId="ADAL" clId="{6CFC2141-1B0A-45D5-9B60-96DCD45AC834}" dt="2025-11-17T16:14:58.916" v="10" actId="478"/>
+          <ac:spMkLst>
+            <pc:docMk/>
+            <pc:sldMk cId="2342404083" sldId="260"/>
+            <ac:spMk id="3" creationId="{70198BDB-1A99-494A-7EF4-ADF5D012DC2D}"/>
           </ac:spMkLst>
         </pc:spChg>
         <pc:spChg chg="add mod">
-          <ac:chgData name="Alex Casson" userId="53cffa54-f866-4b4c-8e51-0383f28edfe1" providerId="ADAL" clId="{2F1F597A-9983-4D95-8A05-48115C0ECFCB}" dt="2025-08-08T05:39:57.975" v="12" actId="14100"/>
+          <ac:chgData name="Alex Casson" userId="53cffa54-f866-4b4c-8e51-0383f28edfe1" providerId="ADAL" clId="{6CFC2141-1B0A-45D5-9B60-96DCD45AC834}" dt="2025-11-17T16:15:21.145" v="15" actId="14100"/>
           <ac:spMkLst>
             <pc:docMk/>
-            <pc:sldMk cId="1081830049" sldId="257"/>
-            <ac:spMk id="7" creationId="{2E68B209-4A88-75BD-6021-73186E6CCF81}"/>
+            <pc:sldMk cId="2342404083" sldId="260"/>
+            <ac:spMk id="6" creationId="{5004BAB1-6A47-58F9-295E-76BF4CCCB87D}"/>
           </ac:spMkLst>
         </pc:spChg>
         <pc:spChg chg="add mod">
-          <ac:chgData name="Alex Casson" userId="53cffa54-f866-4b4c-8e51-0383f28edfe1" providerId="ADAL" clId="{2F1F597A-9983-4D95-8A05-48115C0ECFCB}" dt="2025-08-08T05:40:37.771" v="65" actId="1076"/>
+          <ac:chgData name="Alex Casson" userId="53cffa54-f866-4b4c-8e51-0383f28edfe1" providerId="ADAL" clId="{6CFC2141-1B0A-45D5-9B60-96DCD45AC834}" dt="2025-11-17T16:15:39.387" v="19" actId="14100"/>
           <ac:spMkLst>
             <pc:docMk/>
-            <pc:sldMk cId="1081830049" sldId="257"/>
-            <ac:spMk id="8" creationId="{7BF74E4D-BB08-D267-941C-442B61B33291}"/>
+            <pc:sldMk cId="2342404083" sldId="260"/>
+            <ac:spMk id="7" creationId="{A0C0AF9E-96EB-6CCC-3B9B-0DE15F549580}"/>
           </ac:spMkLst>
         </pc:spChg>
-        <pc:picChg chg="add mod">
-          <ac:chgData name="Alex Casson" userId="53cffa54-f866-4b4c-8e51-0383f28edfe1" providerId="ADAL" clId="{2F1F597A-9983-4D95-8A05-48115C0ECFCB}" dt="2025-08-08T05:39:44.870" v="9" actId="1076"/>
+        <pc:spChg chg="add del mod">
+          <ac:chgData name="Alex Casson" userId="53cffa54-f866-4b4c-8e51-0383f28edfe1" providerId="ADAL" clId="{6CFC2141-1B0A-45D5-9B60-96DCD45AC834}" dt="2025-11-17T16:15:45.472" v="21" actId="478"/>
+          <ac:spMkLst>
+            <pc:docMk/>
+            <pc:sldMk cId="2342404083" sldId="260"/>
+            <ac:spMk id="8" creationId="{84AFD136-A340-D300-C204-B617EE11B843}"/>
+          </ac:spMkLst>
+        </pc:spChg>
+        <pc:spChg chg="add mod">
+          <ac:chgData name="Alex Casson" userId="53cffa54-f866-4b4c-8e51-0383f28edfe1" providerId="ADAL" clId="{6CFC2141-1B0A-45D5-9B60-96DCD45AC834}" dt="2025-11-17T16:16:07.398" v="24" actId="1076"/>
+          <ac:spMkLst>
+            <pc:docMk/>
+            <pc:sldMk cId="2342404083" sldId="260"/>
+            <ac:spMk id="9" creationId="{E0A4B3EC-BD77-D441-24CF-8374FA5762C2}"/>
+          </ac:spMkLst>
+        </pc:spChg>
+        <pc:spChg chg="add mod">
+          <ac:chgData name="Alex Casson" userId="53cffa54-f866-4b4c-8e51-0383f28edfe1" providerId="ADAL" clId="{6CFC2141-1B0A-45D5-9B60-96DCD45AC834}" dt="2025-11-17T16:16:49.187" v="110" actId="14100"/>
+          <ac:spMkLst>
+            <pc:docMk/>
+            <pc:sldMk cId="2342404083" sldId="260"/>
+            <ac:spMk id="10" creationId="{F38FC12B-3811-D71E-31FD-98AA94C05A14}"/>
+          </ac:spMkLst>
+        </pc:spChg>
+        <pc:picChg chg="add">
+          <ac:chgData name="Alex Casson" userId="53cffa54-f866-4b4c-8e51-0383f28edfe1" providerId="ADAL" clId="{6CFC2141-1B0A-45D5-9B60-96DCD45AC834}" dt="2025-11-17T16:15:01.901" v="12" actId="22"/>
           <ac:picMkLst>
             <pc:docMk/>
-            <pc:sldMk cId="1081830049" sldId="257"/>
-            <ac:picMk id="5" creationId="{60F7F5FF-8C9C-7A4B-C5F2-D2A83305C527}"/>
+            <pc:sldMk cId="2342404083" sldId="260"/>
+            <ac:picMk id="5" creationId="{619ECFE3-227B-35C2-1B7E-C927942C7D44}"/>
           </ac:picMkLst>
         </pc:picChg>
         <pc:cxnChg chg="add mod">
-          <ac:chgData name="Alex Casson" userId="53cffa54-f866-4b4c-8e51-0383f28edfe1" providerId="ADAL" clId="{2F1F597A-9983-4D95-8A05-48115C0ECFCB}" dt="2025-08-08T05:40:53.900" v="67" actId="208"/>
+          <ac:chgData name="Alex Casson" userId="53cffa54-f866-4b4c-8e51-0383f28edfe1" providerId="ADAL" clId="{6CFC2141-1B0A-45D5-9B60-96DCD45AC834}" dt="2025-11-17T16:16:07.398" v="24" actId="1076"/>
           <ac:cxnSpMkLst>
             <pc:docMk/>
-            <pc:sldMk cId="1081830049" sldId="257"/>
-            <ac:cxnSpMk id="10" creationId="{E310F588-097E-E8AF-32A8-58099FDA3675}"/>
+            <pc:sldMk cId="2342404083" sldId="260"/>
+            <ac:cxnSpMk id="11" creationId="{E70B96CA-FB7A-3DB5-A5DC-59D3C965442A}"/>
           </ac:cxnSpMkLst>
         </pc:cxnChg>
       </pc:sldChg>
       <pc:sldChg chg="addSp delSp new mod">
-        <pc:chgData name="Alex Casson" userId="53cffa54-f866-4b4c-8e51-0383f28edfe1" providerId="ADAL" clId="{2F1F597A-9983-4D95-8A05-48115C0ECFCB}" dt="2025-08-08T06:00:23.758" v="71" actId="22"/>
+        <pc:chgData name="Alex Casson" userId="53cffa54-f866-4b4c-8e51-0383f28edfe1" providerId="ADAL" clId="{6CFC2141-1B0A-45D5-9B60-96DCD45AC834}" dt="2025-11-17T16:47:47.105" v="114" actId="22"/>
         <pc:sldMkLst>
           <pc:docMk/>
-          <pc:sldMk cId="1539884735" sldId="258"/>
+          <pc:sldMk cId="546382178" sldId="261"/>
         </pc:sldMkLst>
         <pc:spChg chg="del">
-          <ac:chgData name="Alex Casson" userId="53cffa54-f866-4b4c-8e51-0383f28edfe1" providerId="ADAL" clId="{2F1F597A-9983-4D95-8A05-48115C0ECFCB}" dt="2025-08-08T06:00:22.868" v="70" actId="478"/>
+          <ac:chgData name="Alex Casson" userId="53cffa54-f866-4b4c-8e51-0383f28edfe1" providerId="ADAL" clId="{6CFC2141-1B0A-45D5-9B60-96DCD45AC834}" dt="2025-11-17T16:47:46.332" v="113" actId="478"/>
           <ac:spMkLst>
             <pc:docMk/>
-            <pc:sldMk cId="1539884735" sldId="258"/>
-            <ac:spMk id="2" creationId="{52F65140-FCE7-A2E1-A479-1607351B5DAC}"/>
+            <pc:sldMk cId="546382178" sldId="261"/>
+            <ac:spMk id="2" creationId="{F236FFE7-5FC8-0019-F8C3-601C47A29471}"/>
           </ac:spMkLst>
         </pc:spChg>
         <pc:spChg chg="del">
-          <ac:chgData name="Alex Casson" userId="53cffa54-f866-4b4c-8e51-0383f28edfe1" providerId="ADAL" clId="{2F1F597A-9983-4D95-8A05-48115C0ECFCB}" dt="2025-08-08T06:00:20.804" v="69" actId="478"/>
+          <ac:chgData name="Alex Casson" userId="53cffa54-f866-4b4c-8e51-0383f28edfe1" providerId="ADAL" clId="{6CFC2141-1B0A-45D5-9B60-96DCD45AC834}" dt="2025-11-17T16:47:45.578" v="112" actId="478"/>
           <ac:spMkLst>
             <pc:docMk/>
-            <pc:sldMk cId="1539884735" sldId="258"/>
-            <ac:spMk id="3" creationId="{C1B7472C-7607-9C8F-B1AE-AB549E946F51}"/>
+            <pc:sldMk cId="546382178" sldId="261"/>
+            <ac:spMk id="3" creationId="{72EFF187-A181-63E2-E851-F065C41B39AD}"/>
           </ac:spMkLst>
         </pc:spChg>
         <pc:picChg chg="add">
-          <ac:chgData name="Alex Casson" userId="53cffa54-f866-4b4c-8e51-0383f28edfe1" providerId="ADAL" clId="{2F1F597A-9983-4D95-8A05-48115C0ECFCB}" dt="2025-08-08T06:00:23.758" v="71" actId="22"/>
+          <ac:chgData name="Alex Casson" userId="53cffa54-f866-4b4c-8e51-0383f28edfe1" providerId="ADAL" clId="{6CFC2141-1B0A-45D5-9B60-96DCD45AC834}" dt="2025-11-17T16:47:47.105" v="114" actId="22"/>
           <ac:picMkLst>
             <pc:docMk/>
-            <pc:sldMk cId="1539884735" sldId="258"/>
-            <ac:picMk id="5" creationId="{779EE60F-6C5E-059C-7CEA-C74D6026542F}"/>
+            <pc:sldMk cId="546382178" sldId="261"/>
+            <ac:picMk id="5" creationId="{2C923B60-1CA2-0DBE-B883-C2F47D10AB89}"/>
+          </ac:picMkLst>
+        </pc:picChg>
+      </pc:sldChg>
+      <pc:sldChg chg="addSp delSp modSp new mod">
+        <pc:chgData name="Alex Casson" userId="53cffa54-f866-4b4c-8e51-0383f28edfe1" providerId="ADAL" clId="{6CFC2141-1B0A-45D5-9B60-96DCD45AC834}" dt="2025-11-18T20:55:33.420" v="131" actId="14100"/>
+        <pc:sldMkLst>
+          <pc:docMk/>
+          <pc:sldMk cId="2445504685" sldId="262"/>
+        </pc:sldMkLst>
+        <pc:spChg chg="del">
+          <ac:chgData name="Alex Casson" userId="53cffa54-f866-4b4c-8e51-0383f28edfe1" providerId="ADAL" clId="{6CFC2141-1B0A-45D5-9B60-96DCD45AC834}" dt="2025-11-18T20:51:27.710" v="117" actId="478"/>
+          <ac:spMkLst>
+            <pc:docMk/>
+            <pc:sldMk cId="2445504685" sldId="262"/>
+            <ac:spMk id="2" creationId="{86B8E9C9-C2BE-F112-92D5-6B9D00BF5BE5}"/>
+          </ac:spMkLst>
+        </pc:spChg>
+        <pc:spChg chg="del">
+          <ac:chgData name="Alex Casson" userId="53cffa54-f866-4b4c-8e51-0383f28edfe1" providerId="ADAL" clId="{6CFC2141-1B0A-45D5-9B60-96DCD45AC834}" dt="2025-11-18T20:51:27.145" v="116" actId="478"/>
+          <ac:spMkLst>
+            <pc:docMk/>
+            <pc:sldMk cId="2445504685" sldId="262"/>
+            <ac:spMk id="3" creationId="{EAFC785F-A649-B18A-09E5-0513768EDD0C}"/>
+          </ac:spMkLst>
+        </pc:spChg>
+        <pc:spChg chg="add mod">
+          <ac:chgData name="Alex Casson" userId="53cffa54-f866-4b4c-8e51-0383f28edfe1" providerId="ADAL" clId="{6CFC2141-1B0A-45D5-9B60-96DCD45AC834}" dt="2025-11-18T20:54:51.827" v="122" actId="14100"/>
+          <ac:spMkLst>
+            <pc:docMk/>
+            <pc:sldMk cId="2445504685" sldId="262"/>
+            <ac:spMk id="6" creationId="{5A32F099-718A-67EF-7C1C-F93D018B15A2}"/>
+          </ac:spMkLst>
+        </pc:spChg>
+        <pc:spChg chg="add mod">
+          <ac:chgData name="Alex Casson" userId="53cffa54-f866-4b4c-8e51-0383f28edfe1" providerId="ADAL" clId="{6CFC2141-1B0A-45D5-9B60-96DCD45AC834}" dt="2025-11-18T20:55:03.960" v="125" actId="14100"/>
+          <ac:spMkLst>
+            <pc:docMk/>
+            <pc:sldMk cId="2445504685" sldId="262"/>
+            <ac:spMk id="7" creationId="{2B4D3C46-9BE2-0390-6149-C7B4F0F9D813}"/>
+          </ac:spMkLst>
+        </pc:spChg>
+        <pc:spChg chg="add mod">
+          <ac:chgData name="Alex Casson" userId="53cffa54-f866-4b4c-8e51-0383f28edfe1" providerId="ADAL" clId="{6CFC2141-1B0A-45D5-9B60-96DCD45AC834}" dt="2025-11-18T20:55:17.092" v="128" actId="14100"/>
+          <ac:spMkLst>
+            <pc:docMk/>
+            <pc:sldMk cId="2445504685" sldId="262"/>
+            <ac:spMk id="8" creationId="{A2D490B9-382B-E95C-D50F-EBE37BAC526F}"/>
+          </ac:spMkLst>
+        </pc:spChg>
+        <pc:spChg chg="add mod">
+          <ac:chgData name="Alex Casson" userId="53cffa54-f866-4b4c-8e51-0383f28edfe1" providerId="ADAL" clId="{6CFC2141-1B0A-45D5-9B60-96DCD45AC834}" dt="2025-11-18T20:55:33.420" v="131" actId="14100"/>
+          <ac:spMkLst>
+            <pc:docMk/>
+            <pc:sldMk cId="2445504685" sldId="262"/>
+            <ac:spMk id="9" creationId="{5DE855C8-EAA2-BEC8-830B-FA62EA9F13A9}"/>
+          </ac:spMkLst>
+        </pc:spChg>
+        <pc:picChg chg="add">
+          <ac:chgData name="Alex Casson" userId="53cffa54-f866-4b4c-8e51-0383f28edfe1" providerId="ADAL" clId="{6CFC2141-1B0A-45D5-9B60-96DCD45AC834}" dt="2025-11-18T20:51:28.258" v="118" actId="22"/>
+          <ac:picMkLst>
+            <pc:docMk/>
+            <pc:sldMk cId="2445504685" sldId="262"/>
+            <ac:picMk id="5" creationId="{6244A595-1C28-101B-85BF-B53E15DC7179}"/>
+          </ac:picMkLst>
+        </pc:picChg>
+      </pc:sldChg>
+      <pc:sldChg chg="addSp delSp modSp new mod">
+        <pc:chgData name="Alex Casson" userId="53cffa54-f866-4b4c-8e51-0383f28edfe1" providerId="ADAL" clId="{6CFC2141-1B0A-45D5-9B60-96DCD45AC834}" dt="2025-11-18T20:57:16.118" v="136"/>
+        <pc:sldMkLst>
+          <pc:docMk/>
+          <pc:sldMk cId="1347173010" sldId="263"/>
+        </pc:sldMkLst>
+        <pc:spChg chg="del">
+          <ac:chgData name="Alex Casson" userId="53cffa54-f866-4b4c-8e51-0383f28edfe1" providerId="ADAL" clId="{6CFC2141-1B0A-45D5-9B60-96DCD45AC834}" dt="2025-11-18T20:57:10.712" v="134" actId="478"/>
+          <ac:spMkLst>
+            <pc:docMk/>
+            <pc:sldMk cId="1347173010" sldId="263"/>
+            <ac:spMk id="2" creationId="{1E41D1BA-3992-279E-98C7-35D49314DB1B}"/>
+          </ac:spMkLst>
+        </pc:spChg>
+        <pc:spChg chg="del">
+          <ac:chgData name="Alex Casson" userId="53cffa54-f866-4b4c-8e51-0383f28edfe1" providerId="ADAL" clId="{6CFC2141-1B0A-45D5-9B60-96DCD45AC834}" dt="2025-11-18T20:57:10.093" v="133" actId="478"/>
+          <ac:spMkLst>
+            <pc:docMk/>
+            <pc:sldMk cId="1347173010" sldId="263"/>
+            <ac:spMk id="3" creationId="{09E31B4B-BD72-C241-3DC3-B039F1F54AFE}"/>
+          </ac:spMkLst>
+        </pc:spChg>
+        <pc:spChg chg="add mod">
+          <ac:chgData name="Alex Casson" userId="53cffa54-f866-4b4c-8e51-0383f28edfe1" providerId="ADAL" clId="{6CFC2141-1B0A-45D5-9B60-96DCD45AC834}" dt="2025-11-18T20:57:16.118" v="136"/>
+          <ac:spMkLst>
+            <pc:docMk/>
+            <pc:sldMk cId="1347173010" sldId="263"/>
+            <ac:spMk id="6" creationId="{516F22A5-B122-06B2-CB97-AE523D38CB51}"/>
+          </ac:spMkLst>
+        </pc:spChg>
+        <pc:picChg chg="add">
+          <ac:chgData name="Alex Casson" userId="53cffa54-f866-4b4c-8e51-0383f28edfe1" providerId="ADAL" clId="{6CFC2141-1B0A-45D5-9B60-96DCD45AC834}" dt="2025-11-18T20:57:11.333" v="135" actId="22"/>
+          <ac:picMkLst>
+            <pc:docMk/>
+            <pc:sldMk cId="1347173010" sldId="263"/>
+            <ac:picMk id="5" creationId="{F801F91D-4095-EFB8-26D7-7AFDF1477042}"/>
           </ac:picMkLst>
         </pc:picChg>
       </pc:sldChg>
@@ -374,7 +541,7 @@
           <a:p>
             <a:fld id="{9298EC9D-8325-4ACF-84B5-A03B1DD693C8}" type="datetimeFigureOut">
               <a:rPr lang="en-GB" smtClean="0"/>
-              <a:t>08/08/2025</a:t>
+              <a:t>17/11/2025</a:t>
             </a:fld>
             <a:endParaRPr lang="en-GB"/>
           </a:p>
@@ -574,7 +741,7 @@
           <a:p>
             <a:fld id="{9298EC9D-8325-4ACF-84B5-A03B1DD693C8}" type="datetimeFigureOut">
               <a:rPr lang="en-GB" smtClean="0"/>
-              <a:t>08/08/2025</a:t>
+              <a:t>17/11/2025</a:t>
             </a:fld>
             <a:endParaRPr lang="en-GB"/>
           </a:p>
@@ -784,7 +951,7 @@
           <a:p>
             <a:fld id="{9298EC9D-8325-4ACF-84B5-A03B1DD693C8}" type="datetimeFigureOut">
               <a:rPr lang="en-GB" smtClean="0"/>
-              <a:t>08/08/2025</a:t>
+              <a:t>17/11/2025</a:t>
             </a:fld>
             <a:endParaRPr lang="en-GB"/>
           </a:p>
@@ -984,7 +1151,7 @@
           <a:p>
             <a:fld id="{9298EC9D-8325-4ACF-84B5-A03B1DD693C8}" type="datetimeFigureOut">
               <a:rPr lang="en-GB" smtClean="0"/>
-              <a:t>08/08/2025</a:t>
+              <a:t>17/11/2025</a:t>
             </a:fld>
             <a:endParaRPr lang="en-GB"/>
           </a:p>
@@ -1260,7 +1427,7 @@
           <a:p>
             <a:fld id="{9298EC9D-8325-4ACF-84B5-A03B1DD693C8}" type="datetimeFigureOut">
               <a:rPr lang="en-GB" smtClean="0"/>
-              <a:t>08/08/2025</a:t>
+              <a:t>17/11/2025</a:t>
             </a:fld>
             <a:endParaRPr lang="en-GB"/>
           </a:p>
@@ -1528,7 +1695,7 @@
           <a:p>
             <a:fld id="{9298EC9D-8325-4ACF-84B5-A03B1DD693C8}" type="datetimeFigureOut">
               <a:rPr lang="en-GB" smtClean="0"/>
-              <a:t>08/08/2025</a:t>
+              <a:t>17/11/2025</a:t>
             </a:fld>
             <a:endParaRPr lang="en-GB"/>
           </a:p>
@@ -1943,7 +2110,7 @@
           <a:p>
             <a:fld id="{9298EC9D-8325-4ACF-84B5-A03B1DD693C8}" type="datetimeFigureOut">
               <a:rPr lang="en-GB" smtClean="0"/>
-              <a:t>08/08/2025</a:t>
+              <a:t>17/11/2025</a:t>
             </a:fld>
             <a:endParaRPr lang="en-GB"/>
           </a:p>
@@ -2085,7 +2252,7 @@
           <a:p>
             <a:fld id="{9298EC9D-8325-4ACF-84B5-A03B1DD693C8}" type="datetimeFigureOut">
               <a:rPr lang="en-GB" smtClean="0"/>
-              <a:t>08/08/2025</a:t>
+              <a:t>17/11/2025</a:t>
             </a:fld>
             <a:endParaRPr lang="en-GB"/>
           </a:p>
@@ -2198,7 +2365,7 @@
           <a:p>
             <a:fld id="{9298EC9D-8325-4ACF-84B5-A03B1DD693C8}" type="datetimeFigureOut">
               <a:rPr lang="en-GB" smtClean="0"/>
-              <a:t>08/08/2025</a:t>
+              <a:t>17/11/2025</a:t>
             </a:fld>
             <a:endParaRPr lang="en-GB"/>
           </a:p>
@@ -2511,7 +2678,7 @@
           <a:p>
             <a:fld id="{9298EC9D-8325-4ACF-84B5-A03B1DD693C8}" type="datetimeFigureOut">
               <a:rPr lang="en-GB" smtClean="0"/>
-              <a:t>08/08/2025</a:t>
+              <a:t>17/11/2025</a:t>
             </a:fld>
             <a:endParaRPr lang="en-GB"/>
           </a:p>
@@ -2800,7 +2967,7 @@
           <a:p>
             <a:fld id="{9298EC9D-8325-4ACF-84B5-A03B1DD693C8}" type="datetimeFigureOut">
               <a:rPr lang="en-GB" smtClean="0"/>
-              <a:t>08/08/2025</a:t>
+              <a:t>17/11/2025</a:t>
             </a:fld>
             <a:endParaRPr lang="en-GB"/>
           </a:p>
@@ -3043,7 +3210,7 @@
           <a:p>
             <a:fld id="{9298EC9D-8325-4ACF-84B5-A03B1DD693C8}" type="datetimeFigureOut">
               <a:rPr lang="en-GB" smtClean="0"/>
-              <a:t>08/08/2025</a:t>
+              <a:t>17/11/2025</a:t>
             </a:fld>
             <a:endParaRPr lang="en-GB"/>
           </a:p>
@@ -3967,6 +4134,874 @@
 </p:sld>
 </file>
 
+<file path=ppt/slides/slide4.xml><?xml version="1.0" encoding="utf-8"?>
+<p:sld xmlns:a="http://schemas.openxmlformats.org/drawingml/2006/main" xmlns:r="http://schemas.openxmlformats.org/officeDocument/2006/relationships" xmlns:p="http://schemas.openxmlformats.org/presentationml/2006/main">
+  <p:cSld>
+    <p:spTree>
+      <p:nvGrpSpPr>
+        <p:cNvPr id="1" name=""/>
+        <p:cNvGrpSpPr/>
+        <p:nvPr/>
+      </p:nvGrpSpPr>
+      <p:grpSpPr>
+        <a:xfrm>
+          <a:off x="0" y="0"/>
+          <a:ext cx="0" cy="0"/>
+          <a:chOff x="0" y="0"/>
+          <a:chExt cx="0" cy="0"/>
+        </a:xfrm>
+      </p:grpSpPr>
+      <p:pic>
+        <p:nvPicPr>
+          <p:cNvPr id="5" name="Picture 4">
+            <a:extLst>
+              <a:ext uri="{FF2B5EF4-FFF2-40B4-BE49-F238E27FC236}">
+                <a16:creationId xmlns:a16="http://schemas.microsoft.com/office/drawing/2014/main" id="{33DD15CC-2043-EF58-D2C0-908A36FEB1E6}"/>
+              </a:ext>
+            </a:extLst>
+          </p:cNvPr>
+          <p:cNvPicPr>
+            <a:picLocks noChangeAspect="1"/>
+          </p:cNvPicPr>
+          <p:nvPr/>
+        </p:nvPicPr>
+        <p:blipFill>
+          <a:blip r:embed="rId2"/>
+          <a:stretch>
+            <a:fillRect/>
+          </a:stretch>
+        </p:blipFill>
+        <p:spPr>
+          <a:xfrm>
+            <a:off x="965326" y="0"/>
+            <a:ext cx="10261347" cy="6858000"/>
+          </a:xfrm>
+          <a:prstGeom prst="rect">
+            <a:avLst/>
+          </a:prstGeom>
+        </p:spPr>
+      </p:pic>
+      <p:sp>
+        <p:nvSpPr>
+          <p:cNvPr id="6" name="Rectangle 5">
+            <a:extLst>
+              <a:ext uri="{FF2B5EF4-FFF2-40B4-BE49-F238E27FC236}">
+                <a16:creationId xmlns:a16="http://schemas.microsoft.com/office/drawing/2014/main" id="{320E8F30-1B8A-0B6C-9355-1BB1D837E895}"/>
+              </a:ext>
+            </a:extLst>
+          </p:cNvPr>
+          <p:cNvSpPr/>
+          <p:nvPr/>
+        </p:nvSpPr>
+        <p:spPr>
+          <a:xfrm>
+            <a:off x="1389024" y="1332325"/>
+            <a:ext cx="2189063" cy="595865"/>
+          </a:xfrm>
+          <a:prstGeom prst="rect">
+            <a:avLst/>
+          </a:prstGeom>
+          <a:noFill/>
+          <a:ln w="28575">
+            <a:solidFill>
+              <a:srgbClr val="C00000"/>
+            </a:solidFill>
+          </a:ln>
+        </p:spPr>
+        <p:style>
+          <a:lnRef idx="2">
+            <a:schemeClr val="accent1">
+              <a:shade val="15000"/>
+            </a:schemeClr>
+          </a:lnRef>
+          <a:fillRef idx="1">
+            <a:schemeClr val="accent1"/>
+          </a:fillRef>
+          <a:effectRef idx="0">
+            <a:schemeClr val="accent1"/>
+          </a:effectRef>
+          <a:fontRef idx="minor">
+            <a:schemeClr val="lt1"/>
+          </a:fontRef>
+        </p:style>
+        <p:txBody>
+          <a:bodyPr rtlCol="0" anchor="ctr"/>
+          <a:lstStyle/>
+          <a:p>
+            <a:pPr algn="ctr"/>
+            <a:endParaRPr lang="en-GB"/>
+          </a:p>
+        </p:txBody>
+      </p:sp>
+    </p:spTree>
+    <p:extLst>
+      <p:ext uri="{BB962C8B-B14F-4D97-AF65-F5344CB8AC3E}">
+        <p14:creationId xmlns:p14="http://schemas.microsoft.com/office/powerpoint/2010/main" val="2512259164"/>
+      </p:ext>
+    </p:extLst>
+  </p:cSld>
+  <p:clrMapOvr>
+    <a:masterClrMapping/>
+  </p:clrMapOvr>
+</p:sld>
+</file>
+
+<file path=ppt/slides/slide5.xml><?xml version="1.0" encoding="utf-8"?>
+<p:sld xmlns:a="http://schemas.openxmlformats.org/drawingml/2006/main" xmlns:r="http://schemas.openxmlformats.org/officeDocument/2006/relationships" xmlns:p="http://schemas.openxmlformats.org/presentationml/2006/main">
+  <p:cSld>
+    <p:spTree>
+      <p:nvGrpSpPr>
+        <p:cNvPr id="1" name=""/>
+        <p:cNvGrpSpPr/>
+        <p:nvPr/>
+      </p:nvGrpSpPr>
+      <p:grpSpPr>
+        <a:xfrm>
+          <a:off x="0" y="0"/>
+          <a:ext cx="0" cy="0"/>
+          <a:chOff x="0" y="0"/>
+          <a:chExt cx="0" cy="0"/>
+        </a:xfrm>
+      </p:grpSpPr>
+      <p:pic>
+        <p:nvPicPr>
+          <p:cNvPr id="5" name="Picture 4">
+            <a:extLst>
+              <a:ext uri="{FF2B5EF4-FFF2-40B4-BE49-F238E27FC236}">
+                <a16:creationId xmlns:a16="http://schemas.microsoft.com/office/drawing/2014/main" id="{619ECFE3-227B-35C2-1B7E-C927942C7D44}"/>
+              </a:ext>
+            </a:extLst>
+          </p:cNvPr>
+          <p:cNvPicPr>
+            <a:picLocks noChangeAspect="1"/>
+          </p:cNvPicPr>
+          <p:nvPr/>
+        </p:nvPicPr>
+        <p:blipFill>
+          <a:blip r:embed="rId2"/>
+          <a:stretch>
+            <a:fillRect/>
+          </a:stretch>
+        </p:blipFill>
+        <p:spPr>
+          <a:xfrm>
+            <a:off x="965326" y="0"/>
+            <a:ext cx="10261347" cy="6858000"/>
+          </a:xfrm>
+          <a:prstGeom prst="rect">
+            <a:avLst/>
+          </a:prstGeom>
+        </p:spPr>
+      </p:pic>
+      <p:sp>
+        <p:nvSpPr>
+          <p:cNvPr id="6" name="Rectangle 5">
+            <a:extLst>
+              <a:ext uri="{FF2B5EF4-FFF2-40B4-BE49-F238E27FC236}">
+                <a16:creationId xmlns:a16="http://schemas.microsoft.com/office/drawing/2014/main" id="{5004BAB1-6A47-58F9-295E-76BF4CCCB87D}"/>
+              </a:ext>
+            </a:extLst>
+          </p:cNvPr>
+          <p:cNvSpPr/>
+          <p:nvPr/>
+        </p:nvSpPr>
+        <p:spPr>
+          <a:xfrm>
+            <a:off x="4074035" y="5480376"/>
+            <a:ext cx="2189063" cy="172279"/>
+          </a:xfrm>
+          <a:prstGeom prst="rect">
+            <a:avLst/>
+          </a:prstGeom>
+          <a:noFill/>
+          <a:ln w="28575">
+            <a:solidFill>
+              <a:srgbClr val="C00000"/>
+            </a:solidFill>
+          </a:ln>
+        </p:spPr>
+        <p:style>
+          <a:lnRef idx="2">
+            <a:schemeClr val="accent1">
+              <a:shade val="15000"/>
+            </a:schemeClr>
+          </a:lnRef>
+          <a:fillRef idx="1">
+            <a:schemeClr val="accent1"/>
+          </a:fillRef>
+          <a:effectRef idx="0">
+            <a:schemeClr val="accent1"/>
+          </a:effectRef>
+          <a:fontRef idx="minor">
+            <a:schemeClr val="lt1"/>
+          </a:fontRef>
+        </p:style>
+        <p:txBody>
+          <a:bodyPr rtlCol="0" anchor="ctr"/>
+          <a:lstStyle/>
+          <a:p>
+            <a:pPr algn="ctr"/>
+            <a:endParaRPr lang="en-GB"/>
+          </a:p>
+        </p:txBody>
+      </p:sp>
+      <p:sp>
+        <p:nvSpPr>
+          <p:cNvPr id="7" name="Rectangle 6">
+            <a:extLst>
+              <a:ext uri="{FF2B5EF4-FFF2-40B4-BE49-F238E27FC236}">
+                <a16:creationId xmlns:a16="http://schemas.microsoft.com/office/drawing/2014/main" id="{A0C0AF9E-96EB-6CCC-3B9B-0DE15F549580}"/>
+              </a:ext>
+            </a:extLst>
+          </p:cNvPr>
+          <p:cNvSpPr/>
+          <p:nvPr/>
+        </p:nvSpPr>
+        <p:spPr>
+          <a:xfrm>
+            <a:off x="4074034" y="5056791"/>
+            <a:ext cx="2517959" cy="263354"/>
+          </a:xfrm>
+          <a:prstGeom prst="rect">
+            <a:avLst/>
+          </a:prstGeom>
+          <a:noFill/>
+          <a:ln w="28575">
+            <a:solidFill>
+              <a:srgbClr val="C00000"/>
+            </a:solidFill>
+          </a:ln>
+        </p:spPr>
+        <p:style>
+          <a:lnRef idx="2">
+            <a:schemeClr val="accent1">
+              <a:shade val="15000"/>
+            </a:schemeClr>
+          </a:lnRef>
+          <a:fillRef idx="1">
+            <a:schemeClr val="accent1"/>
+          </a:fillRef>
+          <a:effectRef idx="0">
+            <a:schemeClr val="accent1"/>
+          </a:effectRef>
+          <a:fontRef idx="minor">
+            <a:schemeClr val="lt1"/>
+          </a:fontRef>
+        </p:style>
+        <p:txBody>
+          <a:bodyPr rtlCol="0" anchor="ctr"/>
+          <a:lstStyle/>
+          <a:p>
+            <a:pPr algn="ctr"/>
+            <a:endParaRPr lang="en-GB"/>
+          </a:p>
+        </p:txBody>
+      </p:sp>
+      <p:sp>
+        <p:nvSpPr>
+          <p:cNvPr id="9" name="Rectangle 8">
+            <a:extLst>
+              <a:ext uri="{FF2B5EF4-FFF2-40B4-BE49-F238E27FC236}">
+                <a16:creationId xmlns:a16="http://schemas.microsoft.com/office/drawing/2014/main" id="{E0A4B3EC-BD77-D441-24CF-8374FA5762C2}"/>
+              </a:ext>
+            </a:extLst>
+          </p:cNvPr>
+          <p:cNvSpPr/>
+          <p:nvPr/>
+        </p:nvSpPr>
+        <p:spPr>
+          <a:xfrm>
+            <a:off x="10360746" y="340823"/>
+            <a:ext cx="221357" cy="207818"/>
+          </a:xfrm>
+          <a:prstGeom prst="rect">
+            <a:avLst/>
+          </a:prstGeom>
+          <a:noFill/>
+          <a:ln w="28575">
+            <a:solidFill>
+              <a:srgbClr val="C00000"/>
+            </a:solidFill>
+          </a:ln>
+        </p:spPr>
+        <p:style>
+          <a:lnRef idx="2">
+            <a:schemeClr val="accent1">
+              <a:shade val="15000"/>
+            </a:schemeClr>
+          </a:lnRef>
+          <a:fillRef idx="1">
+            <a:schemeClr val="accent1"/>
+          </a:fillRef>
+          <a:effectRef idx="0">
+            <a:schemeClr val="accent1"/>
+          </a:effectRef>
+          <a:fontRef idx="minor">
+            <a:schemeClr val="lt1"/>
+          </a:fontRef>
+        </p:style>
+        <p:txBody>
+          <a:bodyPr rtlCol="0" anchor="ctr"/>
+          <a:lstStyle/>
+          <a:p>
+            <a:pPr algn="ctr"/>
+            <a:endParaRPr lang="en-GB"/>
+          </a:p>
+        </p:txBody>
+      </p:sp>
+      <p:sp>
+        <p:nvSpPr>
+          <p:cNvPr id="10" name="TextBox 9">
+            <a:extLst>
+              <a:ext uri="{FF2B5EF4-FFF2-40B4-BE49-F238E27FC236}">
+                <a16:creationId xmlns:a16="http://schemas.microsoft.com/office/drawing/2014/main" id="{F38FC12B-3811-D71E-31FD-98AA94C05A14}"/>
+              </a:ext>
+            </a:extLst>
+          </p:cNvPr>
+          <p:cNvSpPr txBox="1"/>
+          <p:nvPr/>
+        </p:nvSpPr>
+        <p:spPr>
+          <a:xfrm>
+            <a:off x="8703425" y="2101302"/>
+            <a:ext cx="2419945" cy="1200329"/>
+          </a:xfrm>
+          <a:prstGeom prst="rect">
+            <a:avLst/>
+          </a:prstGeom>
+          <a:noFill/>
+        </p:spPr>
+        <p:txBody>
+          <a:bodyPr wrap="square" rtlCol="0">
+            <a:spAutoFit/>
+          </a:bodyPr>
+          <a:lstStyle/>
+          <a:p>
+            <a:pPr algn="ctr"/>
+            <a:r>
+              <a:rPr lang="en-GB" dirty="0">
+                <a:solidFill>
+                  <a:srgbClr val="C00000"/>
+                </a:solidFill>
+              </a:rPr>
+              <a:t>Run button only works after a </a:t>
+            </a:r>
+            <a:r>
+              <a:rPr lang="en-GB" dirty="0" err="1">
+                <a:solidFill>
+                  <a:srgbClr val="C00000"/>
+                </a:solidFill>
+              </a:rPr>
+              <a:t>venv</a:t>
+            </a:r>
+            <a:r>
+              <a:rPr lang="en-GB" dirty="0">
+                <a:solidFill>
+                  <a:srgbClr val="C00000"/>
+                </a:solidFill>
+              </a:rPr>
+              <a:t> has been created at the command line</a:t>
+            </a:r>
+          </a:p>
+        </p:txBody>
+      </p:sp>
+      <p:cxnSp>
+        <p:nvCxnSpPr>
+          <p:cNvPr id="11" name="Straight Arrow Connector 10">
+            <a:extLst>
+              <a:ext uri="{FF2B5EF4-FFF2-40B4-BE49-F238E27FC236}">
+                <a16:creationId xmlns:a16="http://schemas.microsoft.com/office/drawing/2014/main" id="{E70B96CA-FB7A-3DB5-A5DC-59D3C965442A}"/>
+              </a:ext>
+            </a:extLst>
+          </p:cNvPr>
+          <p:cNvCxnSpPr>
+            <a:endCxn id="9" idx="2"/>
+          </p:cNvCxnSpPr>
+          <p:nvPr/>
+        </p:nvCxnSpPr>
+        <p:spPr>
+          <a:xfrm flipV="1">
+            <a:off x="10471424" y="548641"/>
+            <a:ext cx="1" cy="1527735"/>
+          </a:xfrm>
+          <a:prstGeom prst="straightConnector1">
+            <a:avLst/>
+          </a:prstGeom>
+          <a:ln>
+            <a:solidFill>
+              <a:srgbClr val="C00000"/>
+            </a:solidFill>
+            <a:tailEnd type="triangle"/>
+          </a:ln>
+        </p:spPr>
+        <p:style>
+          <a:lnRef idx="2">
+            <a:schemeClr val="accent1"/>
+          </a:lnRef>
+          <a:fillRef idx="0">
+            <a:schemeClr val="accent1"/>
+          </a:fillRef>
+          <a:effectRef idx="1">
+            <a:schemeClr val="accent1"/>
+          </a:effectRef>
+          <a:fontRef idx="minor">
+            <a:schemeClr val="tx1"/>
+          </a:fontRef>
+        </p:style>
+      </p:cxnSp>
+    </p:spTree>
+    <p:extLst>
+      <p:ext uri="{BB962C8B-B14F-4D97-AF65-F5344CB8AC3E}">
+        <p14:creationId xmlns:p14="http://schemas.microsoft.com/office/powerpoint/2010/main" val="2342404083"/>
+      </p:ext>
+    </p:extLst>
+  </p:cSld>
+  <p:clrMapOvr>
+    <a:masterClrMapping/>
+  </p:clrMapOvr>
+</p:sld>
+</file>
+
+<file path=ppt/slides/slide6.xml><?xml version="1.0" encoding="utf-8"?>
+<p:sld xmlns:a="http://schemas.openxmlformats.org/drawingml/2006/main" xmlns:r="http://schemas.openxmlformats.org/officeDocument/2006/relationships" xmlns:p="http://schemas.openxmlformats.org/presentationml/2006/main">
+  <p:cSld>
+    <p:spTree>
+      <p:nvGrpSpPr>
+        <p:cNvPr id="1" name=""/>
+        <p:cNvGrpSpPr/>
+        <p:nvPr/>
+      </p:nvGrpSpPr>
+      <p:grpSpPr>
+        <a:xfrm>
+          <a:off x="0" y="0"/>
+          <a:ext cx="0" cy="0"/>
+          <a:chOff x="0" y="0"/>
+          <a:chExt cx="0" cy="0"/>
+        </a:xfrm>
+      </p:grpSpPr>
+      <p:pic>
+        <p:nvPicPr>
+          <p:cNvPr id="5" name="Picture 4">
+            <a:extLst>
+              <a:ext uri="{FF2B5EF4-FFF2-40B4-BE49-F238E27FC236}">
+                <a16:creationId xmlns:a16="http://schemas.microsoft.com/office/drawing/2014/main" id="{2C923B60-1CA2-0DBE-B883-C2F47D10AB89}"/>
+              </a:ext>
+            </a:extLst>
+          </p:cNvPr>
+          <p:cNvPicPr>
+            <a:picLocks noChangeAspect="1"/>
+          </p:cNvPicPr>
+          <p:nvPr/>
+        </p:nvPicPr>
+        <p:blipFill>
+          <a:blip r:embed="rId2"/>
+          <a:stretch>
+            <a:fillRect/>
+          </a:stretch>
+        </p:blipFill>
+        <p:spPr>
+          <a:xfrm>
+            <a:off x="2351069" y="0"/>
+            <a:ext cx="7489861" cy="6858000"/>
+          </a:xfrm>
+          <a:prstGeom prst="rect">
+            <a:avLst/>
+          </a:prstGeom>
+        </p:spPr>
+      </p:pic>
+    </p:spTree>
+    <p:extLst>
+      <p:ext uri="{BB962C8B-B14F-4D97-AF65-F5344CB8AC3E}">
+        <p14:creationId xmlns:p14="http://schemas.microsoft.com/office/powerpoint/2010/main" val="546382178"/>
+      </p:ext>
+    </p:extLst>
+  </p:cSld>
+  <p:clrMapOvr>
+    <a:masterClrMapping/>
+  </p:clrMapOvr>
+</p:sld>
+</file>
+
+<file path=ppt/slides/slide7.xml><?xml version="1.0" encoding="utf-8"?>
+<p:sld xmlns:a="http://schemas.openxmlformats.org/drawingml/2006/main" xmlns:r="http://schemas.openxmlformats.org/officeDocument/2006/relationships" xmlns:p="http://schemas.openxmlformats.org/presentationml/2006/main">
+  <p:cSld>
+    <p:spTree>
+      <p:nvGrpSpPr>
+        <p:cNvPr id="1" name=""/>
+        <p:cNvGrpSpPr/>
+        <p:nvPr/>
+      </p:nvGrpSpPr>
+      <p:grpSpPr>
+        <a:xfrm>
+          <a:off x="0" y="0"/>
+          <a:ext cx="0" cy="0"/>
+          <a:chOff x="0" y="0"/>
+          <a:chExt cx="0" cy="0"/>
+        </a:xfrm>
+      </p:grpSpPr>
+      <p:pic>
+        <p:nvPicPr>
+          <p:cNvPr id="5" name="Picture 4">
+            <a:extLst>
+              <a:ext uri="{FF2B5EF4-FFF2-40B4-BE49-F238E27FC236}">
+                <a16:creationId xmlns:a16="http://schemas.microsoft.com/office/drawing/2014/main" id="{6244A595-1C28-101B-85BF-B53E15DC7179}"/>
+              </a:ext>
+            </a:extLst>
+          </p:cNvPr>
+          <p:cNvPicPr>
+            <a:picLocks noChangeAspect="1"/>
+          </p:cNvPicPr>
+          <p:nvPr/>
+        </p:nvPicPr>
+        <p:blipFill>
+          <a:blip r:embed="rId2"/>
+          <a:stretch>
+            <a:fillRect/>
+          </a:stretch>
+        </p:blipFill>
+        <p:spPr>
+          <a:xfrm>
+            <a:off x="965326" y="0"/>
+            <a:ext cx="10261347" cy="6858000"/>
+          </a:xfrm>
+          <a:prstGeom prst="rect">
+            <a:avLst/>
+          </a:prstGeom>
+        </p:spPr>
+      </p:pic>
+      <p:sp>
+        <p:nvSpPr>
+          <p:cNvPr id="6" name="Rectangle 5">
+            <a:extLst>
+              <a:ext uri="{FF2B5EF4-FFF2-40B4-BE49-F238E27FC236}">
+                <a16:creationId xmlns:a16="http://schemas.microsoft.com/office/drawing/2014/main" id="{5A32F099-718A-67EF-7C1C-F93D018B15A2}"/>
+              </a:ext>
+            </a:extLst>
+          </p:cNvPr>
+          <p:cNvSpPr/>
+          <p:nvPr/>
+        </p:nvSpPr>
+        <p:spPr>
+          <a:xfrm>
+            <a:off x="1513714" y="784049"/>
+            <a:ext cx="1196235" cy="279979"/>
+          </a:xfrm>
+          <a:prstGeom prst="rect">
+            <a:avLst/>
+          </a:prstGeom>
+          <a:noFill/>
+          <a:ln w="28575">
+            <a:solidFill>
+              <a:srgbClr val="C00000"/>
+            </a:solidFill>
+          </a:ln>
+        </p:spPr>
+        <p:style>
+          <a:lnRef idx="2">
+            <a:schemeClr val="accent1">
+              <a:shade val="15000"/>
+            </a:schemeClr>
+          </a:lnRef>
+          <a:fillRef idx="1">
+            <a:schemeClr val="accent1"/>
+          </a:fillRef>
+          <a:effectRef idx="0">
+            <a:schemeClr val="accent1"/>
+          </a:effectRef>
+          <a:fontRef idx="minor">
+            <a:schemeClr val="lt1"/>
+          </a:fontRef>
+        </p:style>
+        <p:txBody>
+          <a:bodyPr rtlCol="0" anchor="ctr"/>
+          <a:lstStyle/>
+          <a:p>
+            <a:pPr algn="ctr"/>
+            <a:endParaRPr lang="en-GB"/>
+          </a:p>
+        </p:txBody>
+      </p:sp>
+      <p:sp>
+        <p:nvSpPr>
+          <p:cNvPr id="7" name="Rectangle 6">
+            <a:extLst>
+              <a:ext uri="{FF2B5EF4-FFF2-40B4-BE49-F238E27FC236}">
+                <a16:creationId xmlns:a16="http://schemas.microsoft.com/office/drawing/2014/main" id="{2B4D3C46-9BE2-0390-6149-C7B4F0F9D813}"/>
+              </a:ext>
+            </a:extLst>
+          </p:cNvPr>
+          <p:cNvSpPr/>
+          <p:nvPr/>
+        </p:nvSpPr>
+        <p:spPr>
+          <a:xfrm>
+            <a:off x="965327" y="1158122"/>
+            <a:ext cx="406274" cy="371420"/>
+          </a:xfrm>
+          <a:prstGeom prst="rect">
+            <a:avLst/>
+          </a:prstGeom>
+          <a:noFill/>
+          <a:ln w="28575">
+            <a:solidFill>
+              <a:srgbClr val="C00000"/>
+            </a:solidFill>
+          </a:ln>
+        </p:spPr>
+        <p:style>
+          <a:lnRef idx="2">
+            <a:schemeClr val="accent1">
+              <a:shade val="15000"/>
+            </a:schemeClr>
+          </a:lnRef>
+          <a:fillRef idx="1">
+            <a:schemeClr val="accent1"/>
+          </a:fillRef>
+          <a:effectRef idx="0">
+            <a:schemeClr val="accent1"/>
+          </a:effectRef>
+          <a:fontRef idx="minor">
+            <a:schemeClr val="lt1"/>
+          </a:fontRef>
+        </p:style>
+        <p:txBody>
+          <a:bodyPr rtlCol="0" anchor="ctr"/>
+          <a:lstStyle/>
+          <a:p>
+            <a:pPr algn="ctr"/>
+            <a:endParaRPr lang="en-GB"/>
+          </a:p>
+        </p:txBody>
+      </p:sp>
+      <p:sp>
+        <p:nvSpPr>
+          <p:cNvPr id="8" name="Rectangle 7">
+            <a:extLst>
+              <a:ext uri="{FF2B5EF4-FFF2-40B4-BE49-F238E27FC236}">
+                <a16:creationId xmlns:a16="http://schemas.microsoft.com/office/drawing/2014/main" id="{A2D490B9-382B-E95C-D50F-EBE37BAC526F}"/>
+              </a:ext>
+            </a:extLst>
+          </p:cNvPr>
+          <p:cNvSpPr/>
+          <p:nvPr/>
+        </p:nvSpPr>
+        <p:spPr>
+          <a:xfrm>
+            <a:off x="1513714" y="1080478"/>
+            <a:ext cx="2517959" cy="279978"/>
+          </a:xfrm>
+          <a:prstGeom prst="rect">
+            <a:avLst/>
+          </a:prstGeom>
+          <a:noFill/>
+          <a:ln w="28575">
+            <a:solidFill>
+              <a:srgbClr val="C00000"/>
+            </a:solidFill>
+          </a:ln>
+        </p:spPr>
+        <p:style>
+          <a:lnRef idx="2">
+            <a:schemeClr val="accent1">
+              <a:shade val="15000"/>
+            </a:schemeClr>
+          </a:lnRef>
+          <a:fillRef idx="1">
+            <a:schemeClr val="accent1"/>
+          </a:fillRef>
+          <a:effectRef idx="0">
+            <a:schemeClr val="accent1"/>
+          </a:effectRef>
+          <a:fontRef idx="minor">
+            <a:schemeClr val="lt1"/>
+          </a:fontRef>
+        </p:style>
+        <p:txBody>
+          <a:bodyPr rtlCol="0" anchor="ctr"/>
+          <a:lstStyle/>
+          <a:p>
+            <a:pPr algn="ctr"/>
+            <a:endParaRPr lang="en-GB"/>
+          </a:p>
+        </p:txBody>
+      </p:sp>
+      <p:sp>
+        <p:nvSpPr>
+          <p:cNvPr id="9" name="Rectangle 8">
+            <a:extLst>
+              <a:ext uri="{FF2B5EF4-FFF2-40B4-BE49-F238E27FC236}">
+                <a16:creationId xmlns:a16="http://schemas.microsoft.com/office/drawing/2014/main" id="{5DE855C8-EAA2-BEC8-830B-FA62EA9F13A9}"/>
+              </a:ext>
+            </a:extLst>
+          </p:cNvPr>
+          <p:cNvSpPr/>
+          <p:nvPr/>
+        </p:nvSpPr>
+        <p:spPr>
+          <a:xfrm>
+            <a:off x="3417328" y="520695"/>
+            <a:ext cx="248585" cy="279978"/>
+          </a:xfrm>
+          <a:prstGeom prst="rect">
+            <a:avLst/>
+          </a:prstGeom>
+          <a:noFill/>
+          <a:ln w="28575">
+            <a:solidFill>
+              <a:srgbClr val="C00000"/>
+            </a:solidFill>
+          </a:ln>
+        </p:spPr>
+        <p:style>
+          <a:lnRef idx="2">
+            <a:schemeClr val="accent1">
+              <a:shade val="15000"/>
+            </a:schemeClr>
+          </a:lnRef>
+          <a:fillRef idx="1">
+            <a:schemeClr val="accent1"/>
+          </a:fillRef>
+          <a:effectRef idx="0">
+            <a:schemeClr val="accent1"/>
+          </a:effectRef>
+          <a:fontRef idx="minor">
+            <a:schemeClr val="lt1"/>
+          </a:fontRef>
+        </p:style>
+        <p:txBody>
+          <a:bodyPr rtlCol="0" anchor="ctr"/>
+          <a:lstStyle/>
+          <a:p>
+            <a:pPr algn="ctr"/>
+            <a:endParaRPr lang="en-GB"/>
+          </a:p>
+        </p:txBody>
+      </p:sp>
+    </p:spTree>
+    <p:extLst>
+      <p:ext uri="{BB962C8B-B14F-4D97-AF65-F5344CB8AC3E}">
+        <p14:creationId xmlns:p14="http://schemas.microsoft.com/office/powerpoint/2010/main" val="2445504685"/>
+      </p:ext>
+    </p:extLst>
+  </p:cSld>
+  <p:clrMapOvr>
+    <a:masterClrMapping/>
+  </p:clrMapOvr>
+</p:sld>
+</file>
+
+<file path=ppt/slides/slide8.xml><?xml version="1.0" encoding="utf-8"?>
+<p:sld xmlns:a="http://schemas.openxmlformats.org/drawingml/2006/main" xmlns:r="http://schemas.openxmlformats.org/officeDocument/2006/relationships" xmlns:p="http://schemas.openxmlformats.org/presentationml/2006/main">
+  <p:cSld>
+    <p:spTree>
+      <p:nvGrpSpPr>
+        <p:cNvPr id="1" name=""/>
+        <p:cNvGrpSpPr/>
+        <p:nvPr/>
+      </p:nvGrpSpPr>
+      <p:grpSpPr>
+        <a:xfrm>
+          <a:off x="0" y="0"/>
+          <a:ext cx="0" cy="0"/>
+          <a:chOff x="0" y="0"/>
+          <a:chExt cx="0" cy="0"/>
+        </a:xfrm>
+      </p:grpSpPr>
+      <p:pic>
+        <p:nvPicPr>
+          <p:cNvPr id="5" name="Picture 4">
+            <a:extLst>
+              <a:ext uri="{FF2B5EF4-FFF2-40B4-BE49-F238E27FC236}">
+                <a16:creationId xmlns:a16="http://schemas.microsoft.com/office/drawing/2014/main" id="{F801F91D-4095-EFB8-26D7-7AFDF1477042}"/>
+              </a:ext>
+            </a:extLst>
+          </p:cNvPr>
+          <p:cNvPicPr>
+            <a:picLocks noChangeAspect="1"/>
+          </p:cNvPicPr>
+          <p:nvPr/>
+        </p:nvPicPr>
+        <p:blipFill>
+          <a:blip r:embed="rId2"/>
+          <a:stretch>
+            <a:fillRect/>
+          </a:stretch>
+        </p:blipFill>
+        <p:spPr>
+          <a:xfrm>
+            <a:off x="965326" y="0"/>
+            <a:ext cx="10261347" cy="6858000"/>
+          </a:xfrm>
+          <a:prstGeom prst="rect">
+            <a:avLst/>
+          </a:prstGeom>
+        </p:spPr>
+      </p:pic>
+      <p:sp>
+        <p:nvSpPr>
+          <p:cNvPr id="6" name="Rectangle 5">
+            <a:extLst>
+              <a:ext uri="{FF2B5EF4-FFF2-40B4-BE49-F238E27FC236}">
+                <a16:creationId xmlns:a16="http://schemas.microsoft.com/office/drawing/2014/main" id="{516F22A5-B122-06B2-CB97-AE523D38CB51}"/>
+              </a:ext>
+            </a:extLst>
+          </p:cNvPr>
+          <p:cNvSpPr/>
+          <p:nvPr/>
+        </p:nvSpPr>
+        <p:spPr>
+          <a:xfrm>
+            <a:off x="1513714" y="1080478"/>
+            <a:ext cx="2517959" cy="279978"/>
+          </a:xfrm>
+          <a:prstGeom prst="rect">
+            <a:avLst/>
+          </a:prstGeom>
+          <a:noFill/>
+          <a:ln w="28575">
+            <a:solidFill>
+              <a:srgbClr val="C00000"/>
+            </a:solidFill>
+          </a:ln>
+        </p:spPr>
+        <p:style>
+          <a:lnRef idx="2">
+            <a:schemeClr val="accent1">
+              <a:shade val="15000"/>
+            </a:schemeClr>
+          </a:lnRef>
+          <a:fillRef idx="1">
+            <a:schemeClr val="accent1"/>
+          </a:fillRef>
+          <a:effectRef idx="0">
+            <a:schemeClr val="accent1"/>
+          </a:effectRef>
+          <a:fontRef idx="minor">
+            <a:schemeClr val="lt1"/>
+          </a:fontRef>
+        </p:style>
+        <p:txBody>
+          <a:bodyPr rtlCol="0" anchor="ctr"/>
+          <a:lstStyle/>
+          <a:p>
+            <a:pPr algn="ctr"/>
+            <a:endParaRPr lang="en-GB"/>
+          </a:p>
+        </p:txBody>
+      </p:sp>
+    </p:spTree>
+    <p:extLst>
+      <p:ext uri="{BB962C8B-B14F-4D97-AF65-F5344CB8AC3E}">
+        <p14:creationId xmlns:p14="http://schemas.microsoft.com/office/powerpoint/2010/main" val="1347173010"/>
+      </p:ext>
+    </p:extLst>
+  </p:cSld>
+  <p:clrMapOvr>
+    <a:masterClrMapping/>
+  </p:clrMapOvr>
+</p:sld>
+</file>
+
 <file path=ppt/theme/theme1.xml><?xml version="1.0" encoding="utf-8"?>
 <a:theme xmlns:a="http://schemas.openxmlformats.org/drawingml/2006/main" name="Office Theme">
   <a:themeElements>

</xml_diff>

<commit_message>
Added second part of Lab B
</commit_message>
<xml_diff>
--- a/docs/chapters/week3/images.pptx
+++ b/docs/chapters/week3/images.pptx
@@ -13,6 +13,12 @@
     <p:sldId id="261" r:id="rId7"/>
     <p:sldId id="262" r:id="rId8"/>
     <p:sldId id="263" r:id="rId9"/>
+    <p:sldId id="264" r:id="rId10"/>
+    <p:sldId id="265" r:id="rId11"/>
+    <p:sldId id="266" r:id="rId12"/>
+    <p:sldId id="269" r:id="rId13"/>
+    <p:sldId id="267" r:id="rId14"/>
+    <p:sldId id="268" r:id="rId15"/>
   </p:sldIdLst>
   <p:sldSz cx="12192000" cy="6858000"/>
   <p:notesSz cx="6858000" cy="9144000"/>
@@ -122,7 +128,7 @@
 <file path=ppt/revisionInfo.xml><?xml version="1.0" encoding="utf-8"?>
 <p1510:revInfo xmlns:a="http://schemas.openxmlformats.org/drawingml/2006/main" xmlns:r="http://schemas.openxmlformats.org/officeDocument/2006/relationships" xmlns:p1510="http://schemas.microsoft.com/office/powerpoint/2015/10/main">
   <p1510:revLst>
-    <p1510:client id="{6754D92A-69B0-4ED5-949C-BCEED9E812F5}" v="5" dt="2025-11-18T20:57:16.118"/>
+    <p1510:client id="{6754D92A-69B0-4ED5-949C-BCEED9E812F5}" v="13" dt="2025-12-03T09:20:27.457"/>
   </p1510:revLst>
 </p1510:revInfo>
 </file>
@@ -132,7 +138,7 @@
   <pc:docChgLst>
     <pc:chgData name="Alex Casson" userId="53cffa54-f866-4b4c-8e51-0383f28edfe1" providerId="ADAL" clId="{6CFC2141-1B0A-45D5-9B60-96DCD45AC834}"/>
     <pc:docChg chg="custSel addSld modSld sldOrd">
-      <pc:chgData name="Alex Casson" userId="53cffa54-f866-4b4c-8e51-0383f28edfe1" providerId="ADAL" clId="{6CFC2141-1B0A-45D5-9B60-96DCD45AC834}" dt="2025-11-18T20:57:16.118" v="136"/>
+      <pc:chgData name="Alex Casson" userId="53cffa54-f866-4b4c-8e51-0383f28edfe1" providerId="ADAL" clId="{6CFC2141-1B0A-45D5-9B60-96DCD45AC834}" dt="2025-12-03T09:48:43.387" v="221" actId="22"/>
       <pc:docMkLst>
         <pc:docMk/>
       </pc:docMkLst>
@@ -142,22 +148,6 @@
           <pc:docMk/>
           <pc:sldMk cId="2512259164" sldId="259"/>
         </pc:sldMkLst>
-        <pc:spChg chg="del">
-          <ac:chgData name="Alex Casson" userId="53cffa54-f866-4b4c-8e51-0383f28edfe1" providerId="ADAL" clId="{6CFC2141-1B0A-45D5-9B60-96DCD45AC834}" dt="2025-11-17T16:02:17.178" v="2" actId="478"/>
-          <ac:spMkLst>
-            <pc:docMk/>
-            <pc:sldMk cId="2512259164" sldId="259"/>
-            <ac:spMk id="2" creationId="{87797055-625E-2C6B-B869-D2D5E1B20525}"/>
-          </ac:spMkLst>
-        </pc:spChg>
-        <pc:spChg chg="del">
-          <ac:chgData name="Alex Casson" userId="53cffa54-f866-4b4c-8e51-0383f28edfe1" providerId="ADAL" clId="{6CFC2141-1B0A-45D5-9B60-96DCD45AC834}" dt="2025-11-17T16:02:15.323" v="1" actId="478"/>
-          <ac:spMkLst>
-            <pc:docMk/>
-            <pc:sldMk cId="2512259164" sldId="259"/>
-            <ac:spMk id="3" creationId="{9AA3A382-A011-0A3A-A7A3-1C9CD34D13A8}"/>
-          </ac:spMkLst>
-        </pc:spChg>
         <pc:spChg chg="add mod">
           <ac:chgData name="Alex Casson" userId="53cffa54-f866-4b4c-8e51-0383f28edfe1" providerId="ADAL" clId="{6CFC2141-1B0A-45D5-9B60-96DCD45AC834}" dt="2025-11-17T16:02:37.496" v="8" actId="14100"/>
           <ac:spMkLst>
@@ -181,22 +171,6 @@
           <pc:docMk/>
           <pc:sldMk cId="2342404083" sldId="260"/>
         </pc:sldMkLst>
-        <pc:spChg chg="del">
-          <ac:chgData name="Alex Casson" userId="53cffa54-f866-4b4c-8e51-0383f28edfe1" providerId="ADAL" clId="{6CFC2141-1B0A-45D5-9B60-96DCD45AC834}" dt="2025-11-17T16:15:00.899" v="11" actId="478"/>
-          <ac:spMkLst>
-            <pc:docMk/>
-            <pc:sldMk cId="2342404083" sldId="260"/>
-            <ac:spMk id="2" creationId="{9D8A0B13-6971-DF51-BB40-B3552A1E9AA4}"/>
-          </ac:spMkLst>
-        </pc:spChg>
-        <pc:spChg chg="del">
-          <ac:chgData name="Alex Casson" userId="53cffa54-f866-4b4c-8e51-0383f28edfe1" providerId="ADAL" clId="{6CFC2141-1B0A-45D5-9B60-96DCD45AC834}" dt="2025-11-17T16:14:58.916" v="10" actId="478"/>
-          <ac:spMkLst>
-            <pc:docMk/>
-            <pc:sldMk cId="2342404083" sldId="260"/>
-            <ac:spMk id="3" creationId="{70198BDB-1A99-494A-7EF4-ADF5D012DC2D}"/>
-          </ac:spMkLst>
-        </pc:spChg>
         <pc:spChg chg="add mod">
           <ac:chgData name="Alex Casson" userId="53cffa54-f866-4b4c-8e51-0383f28edfe1" providerId="ADAL" clId="{6CFC2141-1B0A-45D5-9B60-96DCD45AC834}" dt="2025-11-17T16:15:21.145" v="15" actId="14100"/>
           <ac:spMkLst>
@@ -211,14 +185,6 @@
             <pc:docMk/>
             <pc:sldMk cId="2342404083" sldId="260"/>
             <ac:spMk id="7" creationId="{A0C0AF9E-96EB-6CCC-3B9B-0DE15F549580}"/>
-          </ac:spMkLst>
-        </pc:spChg>
-        <pc:spChg chg="add del mod">
-          <ac:chgData name="Alex Casson" userId="53cffa54-f866-4b4c-8e51-0383f28edfe1" providerId="ADAL" clId="{6CFC2141-1B0A-45D5-9B60-96DCD45AC834}" dt="2025-11-17T16:15:45.472" v="21" actId="478"/>
-          <ac:spMkLst>
-            <pc:docMk/>
-            <pc:sldMk cId="2342404083" sldId="260"/>
-            <ac:spMk id="8" creationId="{84AFD136-A340-D300-C204-B617EE11B843}"/>
           </ac:spMkLst>
         </pc:spChg>
         <pc:spChg chg="add mod">
@@ -260,22 +226,6 @@
           <pc:docMk/>
           <pc:sldMk cId="546382178" sldId="261"/>
         </pc:sldMkLst>
-        <pc:spChg chg="del">
-          <ac:chgData name="Alex Casson" userId="53cffa54-f866-4b4c-8e51-0383f28edfe1" providerId="ADAL" clId="{6CFC2141-1B0A-45D5-9B60-96DCD45AC834}" dt="2025-11-17T16:47:46.332" v="113" actId="478"/>
-          <ac:spMkLst>
-            <pc:docMk/>
-            <pc:sldMk cId="546382178" sldId="261"/>
-            <ac:spMk id="2" creationId="{F236FFE7-5FC8-0019-F8C3-601C47A29471}"/>
-          </ac:spMkLst>
-        </pc:spChg>
-        <pc:spChg chg="del">
-          <ac:chgData name="Alex Casson" userId="53cffa54-f866-4b4c-8e51-0383f28edfe1" providerId="ADAL" clId="{6CFC2141-1B0A-45D5-9B60-96DCD45AC834}" dt="2025-11-17T16:47:45.578" v="112" actId="478"/>
-          <ac:spMkLst>
-            <pc:docMk/>
-            <pc:sldMk cId="546382178" sldId="261"/>
-            <ac:spMk id="3" creationId="{72EFF187-A181-63E2-E851-F065C41B39AD}"/>
-          </ac:spMkLst>
-        </pc:spChg>
         <pc:picChg chg="add">
           <ac:chgData name="Alex Casson" userId="53cffa54-f866-4b4c-8e51-0383f28edfe1" providerId="ADAL" clId="{6CFC2141-1B0A-45D5-9B60-96DCD45AC834}" dt="2025-11-17T16:47:47.105" v="114" actId="22"/>
           <ac:picMkLst>
@@ -291,22 +241,6 @@
           <pc:docMk/>
           <pc:sldMk cId="2445504685" sldId="262"/>
         </pc:sldMkLst>
-        <pc:spChg chg="del">
-          <ac:chgData name="Alex Casson" userId="53cffa54-f866-4b4c-8e51-0383f28edfe1" providerId="ADAL" clId="{6CFC2141-1B0A-45D5-9B60-96DCD45AC834}" dt="2025-11-18T20:51:27.710" v="117" actId="478"/>
-          <ac:spMkLst>
-            <pc:docMk/>
-            <pc:sldMk cId="2445504685" sldId="262"/>
-            <ac:spMk id="2" creationId="{86B8E9C9-C2BE-F112-92D5-6B9D00BF5BE5}"/>
-          </ac:spMkLst>
-        </pc:spChg>
-        <pc:spChg chg="del">
-          <ac:chgData name="Alex Casson" userId="53cffa54-f866-4b4c-8e51-0383f28edfe1" providerId="ADAL" clId="{6CFC2141-1B0A-45D5-9B60-96DCD45AC834}" dt="2025-11-18T20:51:27.145" v="116" actId="478"/>
-          <ac:spMkLst>
-            <pc:docMk/>
-            <pc:sldMk cId="2445504685" sldId="262"/>
-            <ac:spMk id="3" creationId="{EAFC785F-A649-B18A-09E5-0513768EDD0C}"/>
-          </ac:spMkLst>
-        </pc:spChg>
         <pc:spChg chg="add mod">
           <ac:chgData name="Alex Casson" userId="53cffa54-f866-4b4c-8e51-0383f28edfe1" providerId="ADAL" clId="{6CFC2141-1B0A-45D5-9B60-96DCD45AC834}" dt="2025-11-18T20:54:51.827" v="122" actId="14100"/>
           <ac:spMkLst>
@@ -354,22 +288,6 @@
           <pc:docMk/>
           <pc:sldMk cId="1347173010" sldId="263"/>
         </pc:sldMkLst>
-        <pc:spChg chg="del">
-          <ac:chgData name="Alex Casson" userId="53cffa54-f866-4b4c-8e51-0383f28edfe1" providerId="ADAL" clId="{6CFC2141-1B0A-45D5-9B60-96DCD45AC834}" dt="2025-11-18T20:57:10.712" v="134" actId="478"/>
-          <ac:spMkLst>
-            <pc:docMk/>
-            <pc:sldMk cId="1347173010" sldId="263"/>
-            <ac:spMk id="2" creationId="{1E41D1BA-3992-279E-98C7-35D49314DB1B}"/>
-          </ac:spMkLst>
-        </pc:spChg>
-        <pc:spChg chg="del">
-          <ac:chgData name="Alex Casson" userId="53cffa54-f866-4b4c-8e51-0383f28edfe1" providerId="ADAL" clId="{6CFC2141-1B0A-45D5-9B60-96DCD45AC834}" dt="2025-11-18T20:57:10.093" v="133" actId="478"/>
-          <ac:spMkLst>
-            <pc:docMk/>
-            <pc:sldMk cId="1347173010" sldId="263"/>
-            <ac:spMk id="3" creationId="{09E31B4B-BD72-C241-3DC3-B039F1F54AFE}"/>
-          </ac:spMkLst>
-        </pc:spChg>
         <pc:spChg chg="add mod">
           <ac:chgData name="Alex Casson" userId="53cffa54-f866-4b4c-8e51-0383f28edfe1" providerId="ADAL" clId="{6CFC2141-1B0A-45D5-9B60-96DCD45AC834}" dt="2025-11-18T20:57:16.118" v="136"/>
           <ac:spMkLst>
@@ -384,6 +302,184 @@
             <pc:docMk/>
             <pc:sldMk cId="1347173010" sldId="263"/>
             <ac:picMk id="5" creationId="{F801F91D-4095-EFB8-26D7-7AFDF1477042}"/>
+          </ac:picMkLst>
+        </pc:picChg>
+      </pc:sldChg>
+      <pc:sldChg chg="addSp delSp modSp new mod">
+        <pc:chgData name="Alex Casson" userId="53cffa54-f866-4b4c-8e51-0383f28edfe1" providerId="ADAL" clId="{6CFC2141-1B0A-45D5-9B60-96DCD45AC834}" dt="2025-11-20T20:21:25.726" v="144" actId="14100"/>
+        <pc:sldMkLst>
+          <pc:docMk/>
+          <pc:sldMk cId="630378577" sldId="264"/>
+        </pc:sldMkLst>
+        <pc:spChg chg="add mod">
+          <ac:chgData name="Alex Casson" userId="53cffa54-f866-4b4c-8e51-0383f28edfe1" providerId="ADAL" clId="{6CFC2141-1B0A-45D5-9B60-96DCD45AC834}" dt="2025-11-20T20:21:25.726" v="144" actId="14100"/>
+          <ac:spMkLst>
+            <pc:docMk/>
+            <pc:sldMk cId="630378577" sldId="264"/>
+            <ac:spMk id="6" creationId="{EC86F9EB-B7C4-09F7-7912-824EB010CB3E}"/>
+          </ac:spMkLst>
+        </pc:spChg>
+        <pc:picChg chg="add">
+          <ac:chgData name="Alex Casson" userId="53cffa54-f866-4b4c-8e51-0383f28edfe1" providerId="ADAL" clId="{6CFC2141-1B0A-45D5-9B60-96DCD45AC834}" dt="2025-11-20T20:20:43.275" v="140" actId="22"/>
+          <ac:picMkLst>
+            <pc:docMk/>
+            <pc:sldMk cId="630378577" sldId="264"/>
+            <ac:picMk id="5" creationId="{C3381357-ABC9-858B-A06D-A3FC472E53C4}"/>
+          </ac:picMkLst>
+        </pc:picChg>
+      </pc:sldChg>
+      <pc:sldChg chg="addSp delSp modSp new mod">
+        <pc:chgData name="Alex Casson" userId="53cffa54-f866-4b4c-8e51-0383f28edfe1" providerId="ADAL" clId="{6CFC2141-1B0A-45D5-9B60-96DCD45AC834}" dt="2025-11-20T20:28:18.157" v="198" actId="1076"/>
+        <pc:sldMkLst>
+          <pc:docMk/>
+          <pc:sldMk cId="3232102836" sldId="265"/>
+        </pc:sldMkLst>
+        <pc:spChg chg="add mod">
+          <ac:chgData name="Alex Casson" userId="53cffa54-f866-4b4c-8e51-0383f28edfe1" providerId="ADAL" clId="{6CFC2141-1B0A-45D5-9B60-96DCD45AC834}" dt="2025-11-20T20:27:31.096" v="151" actId="14100"/>
+          <ac:spMkLst>
+            <pc:docMk/>
+            <pc:sldMk cId="3232102836" sldId="265"/>
+            <ac:spMk id="6" creationId="{AA6E6BF6-814D-9106-B9BE-A4AEE55FC0B3}"/>
+          </ac:spMkLst>
+        </pc:spChg>
+        <pc:spChg chg="add mod">
+          <ac:chgData name="Alex Casson" userId="53cffa54-f866-4b4c-8e51-0383f28edfe1" providerId="ADAL" clId="{6CFC2141-1B0A-45D5-9B60-96DCD45AC834}" dt="2025-11-20T20:27:38.189" v="154" actId="14100"/>
+          <ac:spMkLst>
+            <pc:docMk/>
+            <pc:sldMk cId="3232102836" sldId="265"/>
+            <ac:spMk id="7" creationId="{A6A3AF9B-D373-62F3-A535-7484642FA39A}"/>
+          </ac:spMkLst>
+        </pc:spChg>
+        <pc:spChg chg="add mod">
+          <ac:chgData name="Alex Casson" userId="53cffa54-f866-4b4c-8e51-0383f28edfe1" providerId="ADAL" clId="{6CFC2141-1B0A-45D5-9B60-96DCD45AC834}" dt="2025-11-20T20:27:53.258" v="158" actId="14100"/>
+          <ac:spMkLst>
+            <pc:docMk/>
+            <pc:sldMk cId="3232102836" sldId="265"/>
+            <ac:spMk id="8" creationId="{5B1B194C-07D7-8055-2D16-0AC38959C0CF}"/>
+          </ac:spMkLst>
+        </pc:spChg>
+        <pc:spChg chg="add mod">
+          <ac:chgData name="Alex Casson" userId="53cffa54-f866-4b4c-8e51-0383f28edfe1" providerId="ADAL" clId="{6CFC2141-1B0A-45D5-9B60-96DCD45AC834}" dt="2025-11-20T20:28:07.558" v="179" actId="1076"/>
+          <ac:spMkLst>
+            <pc:docMk/>
+            <pc:sldMk cId="3232102836" sldId="265"/>
+            <ac:spMk id="9" creationId="{085A1F90-4066-9569-1CE4-F8237598EEDD}"/>
+          </ac:spMkLst>
+        </pc:spChg>
+        <pc:spChg chg="add mod">
+          <ac:chgData name="Alex Casson" userId="53cffa54-f866-4b4c-8e51-0383f28edfe1" providerId="ADAL" clId="{6CFC2141-1B0A-45D5-9B60-96DCD45AC834}" dt="2025-11-20T20:28:18.157" v="198" actId="1076"/>
+          <ac:spMkLst>
+            <pc:docMk/>
+            <pc:sldMk cId="3232102836" sldId="265"/>
+            <ac:spMk id="10" creationId="{3CCA8B45-0E3C-D5BB-8032-33542ADBFF54}"/>
+          </ac:spMkLst>
+        </pc:spChg>
+        <pc:picChg chg="add">
+          <ac:chgData name="Alex Casson" userId="53cffa54-f866-4b4c-8e51-0383f28edfe1" providerId="ADAL" clId="{6CFC2141-1B0A-45D5-9B60-96DCD45AC834}" dt="2025-11-20T20:26:28.614" v="148" actId="22"/>
+          <ac:picMkLst>
+            <pc:docMk/>
+            <pc:sldMk cId="3232102836" sldId="265"/>
+            <ac:picMk id="5" creationId="{271C4D88-962B-B27E-4096-68DA3C8A9F3A}"/>
+          </ac:picMkLst>
+        </pc:picChg>
+      </pc:sldChg>
+      <pc:sldChg chg="addSp delSp modSp new mod">
+        <pc:chgData name="Alex Casson" userId="53cffa54-f866-4b4c-8e51-0383f28edfe1" providerId="ADAL" clId="{6CFC2141-1B0A-45D5-9B60-96DCD45AC834}" dt="2025-11-20T20:38:35.795" v="206" actId="14100"/>
+        <pc:sldMkLst>
+          <pc:docMk/>
+          <pc:sldMk cId="2446759160" sldId="266"/>
+        </pc:sldMkLst>
+        <pc:spChg chg="add mod">
+          <ac:chgData name="Alex Casson" userId="53cffa54-f866-4b4c-8e51-0383f28edfe1" providerId="ADAL" clId="{6CFC2141-1B0A-45D5-9B60-96DCD45AC834}" dt="2025-11-20T20:38:35.795" v="206" actId="14100"/>
+          <ac:spMkLst>
+            <pc:docMk/>
+            <pc:sldMk cId="2446759160" sldId="266"/>
+            <ac:spMk id="6" creationId="{B4989424-24FC-F56C-B95A-B5978310E32B}"/>
+          </ac:spMkLst>
+        </pc:spChg>
+        <pc:picChg chg="add">
+          <ac:chgData name="Alex Casson" userId="53cffa54-f866-4b4c-8e51-0383f28edfe1" providerId="ADAL" clId="{6CFC2141-1B0A-45D5-9B60-96DCD45AC834}" dt="2025-11-20T20:38:11.287" v="202" actId="22"/>
+          <ac:picMkLst>
+            <pc:docMk/>
+            <pc:sldMk cId="2446759160" sldId="266"/>
+            <ac:picMk id="5" creationId="{F13740C8-6FE7-F756-4EF3-618A8393FC35}"/>
+          </ac:picMkLst>
+        </pc:picChg>
+      </pc:sldChg>
+      <pc:sldChg chg="addSp delSp modSp new mod ord">
+        <pc:chgData name="Alex Casson" userId="53cffa54-f866-4b4c-8e51-0383f28edfe1" providerId="ADAL" clId="{6CFC2141-1B0A-45D5-9B60-96DCD45AC834}" dt="2025-12-03T09:20:36.806" v="216" actId="14100"/>
+        <pc:sldMkLst>
+          <pc:docMk/>
+          <pc:sldMk cId="3419318905" sldId="267"/>
+        </pc:sldMkLst>
+        <pc:spChg chg="del">
+          <ac:chgData name="Alex Casson" userId="53cffa54-f866-4b4c-8e51-0383f28edfe1" providerId="ADAL" clId="{6CFC2141-1B0A-45D5-9B60-96DCD45AC834}" dt="2025-12-03T09:20:07.657" v="209" actId="478"/>
+          <ac:spMkLst>
+            <pc:docMk/>
+            <pc:sldMk cId="3419318905" sldId="267"/>
+            <ac:spMk id="2" creationId="{275EAFAF-BF8B-09F1-347D-B2536E37D157}"/>
+          </ac:spMkLst>
+        </pc:spChg>
+        <pc:spChg chg="del">
+          <ac:chgData name="Alex Casson" userId="53cffa54-f866-4b4c-8e51-0383f28edfe1" providerId="ADAL" clId="{6CFC2141-1B0A-45D5-9B60-96DCD45AC834}" dt="2025-12-03T09:20:06.454" v="208" actId="478"/>
+          <ac:spMkLst>
+            <pc:docMk/>
+            <pc:sldMk cId="3419318905" sldId="267"/>
+            <ac:spMk id="3" creationId="{95EAC484-4577-EA04-823A-5223162189E5}"/>
+          </ac:spMkLst>
+        </pc:spChg>
+        <pc:spChg chg="add mod">
+          <ac:chgData name="Alex Casson" userId="53cffa54-f866-4b4c-8e51-0383f28edfe1" providerId="ADAL" clId="{6CFC2141-1B0A-45D5-9B60-96DCD45AC834}" dt="2025-12-03T09:20:36.806" v="216" actId="14100"/>
+          <ac:spMkLst>
+            <pc:docMk/>
+            <pc:sldMk cId="3419318905" sldId="267"/>
+            <ac:spMk id="6" creationId="{FD7CE4DC-7CD7-55F1-4615-5C715840C5CC}"/>
+          </ac:spMkLst>
+        </pc:spChg>
+        <pc:picChg chg="add">
+          <ac:chgData name="Alex Casson" userId="53cffa54-f866-4b4c-8e51-0383f28edfe1" providerId="ADAL" clId="{6CFC2141-1B0A-45D5-9B60-96DCD45AC834}" dt="2025-12-03T09:20:12.674" v="212" actId="22"/>
+          <ac:picMkLst>
+            <pc:docMk/>
+            <pc:sldMk cId="3419318905" sldId="267"/>
+            <ac:picMk id="5" creationId="{EE1CA0F7-D262-6C35-8DF7-458833251245}"/>
+          </ac:picMkLst>
+        </pc:picChg>
+      </pc:sldChg>
+      <pc:sldChg chg="new">
+        <pc:chgData name="Alex Casson" userId="53cffa54-f866-4b4c-8e51-0383f28edfe1" providerId="ADAL" clId="{6CFC2141-1B0A-45D5-9B60-96DCD45AC834}" dt="2025-12-03T09:21:28.430" v="217" actId="680"/>
+        <pc:sldMkLst>
+          <pc:docMk/>
+          <pc:sldMk cId="326291998" sldId="268"/>
+        </pc:sldMkLst>
+      </pc:sldChg>
+      <pc:sldChg chg="addSp delSp new mod">
+        <pc:chgData name="Alex Casson" userId="53cffa54-f866-4b4c-8e51-0383f28edfe1" providerId="ADAL" clId="{6CFC2141-1B0A-45D5-9B60-96DCD45AC834}" dt="2025-12-03T09:48:43.387" v="221" actId="22"/>
+        <pc:sldMkLst>
+          <pc:docMk/>
+          <pc:sldMk cId="389197133" sldId="269"/>
+        </pc:sldMkLst>
+        <pc:spChg chg="del">
+          <ac:chgData name="Alex Casson" userId="53cffa54-f866-4b4c-8e51-0383f28edfe1" providerId="ADAL" clId="{6CFC2141-1B0A-45D5-9B60-96DCD45AC834}" dt="2025-12-03T09:48:42.092" v="219" actId="478"/>
+          <ac:spMkLst>
+            <pc:docMk/>
+            <pc:sldMk cId="389197133" sldId="269"/>
+            <ac:spMk id="2" creationId="{A16771AE-0240-FBDB-3AE1-5557ACA41355}"/>
+          </ac:spMkLst>
+        </pc:spChg>
+        <pc:spChg chg="del">
+          <ac:chgData name="Alex Casson" userId="53cffa54-f866-4b4c-8e51-0383f28edfe1" providerId="ADAL" clId="{6CFC2141-1B0A-45D5-9B60-96DCD45AC834}" dt="2025-12-03T09:48:42.785" v="220" actId="478"/>
+          <ac:spMkLst>
+            <pc:docMk/>
+            <pc:sldMk cId="389197133" sldId="269"/>
+            <ac:spMk id="3" creationId="{4C733657-5F70-76AE-AF35-4250EC3166F5}"/>
+          </ac:spMkLst>
+        </pc:spChg>
+        <pc:picChg chg="add">
+          <ac:chgData name="Alex Casson" userId="53cffa54-f866-4b4c-8e51-0383f28edfe1" providerId="ADAL" clId="{6CFC2141-1B0A-45D5-9B60-96DCD45AC834}" dt="2025-12-03T09:48:43.387" v="221" actId="22"/>
+          <ac:picMkLst>
+            <pc:docMk/>
+            <pc:sldMk cId="389197133" sldId="269"/>
+            <ac:picMk id="5" creationId="{A296AC05-9F6B-FE78-D044-CF417F668B29}"/>
           </ac:picMkLst>
         </pc:picChg>
       </pc:sldChg>
@@ -541,7 +637,7 @@
           <a:p>
             <a:fld id="{9298EC9D-8325-4ACF-84B5-A03B1DD693C8}" type="datetimeFigureOut">
               <a:rPr lang="en-GB" smtClean="0"/>
-              <a:t>17/11/2025</a:t>
+              <a:t>03/12/2025</a:t>
             </a:fld>
             <a:endParaRPr lang="en-GB"/>
           </a:p>
@@ -741,7 +837,7 @@
           <a:p>
             <a:fld id="{9298EC9D-8325-4ACF-84B5-A03B1DD693C8}" type="datetimeFigureOut">
               <a:rPr lang="en-GB" smtClean="0"/>
-              <a:t>17/11/2025</a:t>
+              <a:t>03/12/2025</a:t>
             </a:fld>
             <a:endParaRPr lang="en-GB"/>
           </a:p>
@@ -951,7 +1047,7 @@
           <a:p>
             <a:fld id="{9298EC9D-8325-4ACF-84B5-A03B1DD693C8}" type="datetimeFigureOut">
               <a:rPr lang="en-GB" smtClean="0"/>
-              <a:t>17/11/2025</a:t>
+              <a:t>03/12/2025</a:t>
             </a:fld>
             <a:endParaRPr lang="en-GB"/>
           </a:p>
@@ -1151,7 +1247,7 @@
           <a:p>
             <a:fld id="{9298EC9D-8325-4ACF-84B5-A03B1DD693C8}" type="datetimeFigureOut">
               <a:rPr lang="en-GB" smtClean="0"/>
-              <a:t>17/11/2025</a:t>
+              <a:t>03/12/2025</a:t>
             </a:fld>
             <a:endParaRPr lang="en-GB"/>
           </a:p>
@@ -1427,7 +1523,7 @@
           <a:p>
             <a:fld id="{9298EC9D-8325-4ACF-84B5-A03B1DD693C8}" type="datetimeFigureOut">
               <a:rPr lang="en-GB" smtClean="0"/>
-              <a:t>17/11/2025</a:t>
+              <a:t>03/12/2025</a:t>
             </a:fld>
             <a:endParaRPr lang="en-GB"/>
           </a:p>
@@ -1695,7 +1791,7 @@
           <a:p>
             <a:fld id="{9298EC9D-8325-4ACF-84B5-A03B1DD693C8}" type="datetimeFigureOut">
               <a:rPr lang="en-GB" smtClean="0"/>
-              <a:t>17/11/2025</a:t>
+              <a:t>03/12/2025</a:t>
             </a:fld>
             <a:endParaRPr lang="en-GB"/>
           </a:p>
@@ -2110,7 +2206,7 @@
           <a:p>
             <a:fld id="{9298EC9D-8325-4ACF-84B5-A03B1DD693C8}" type="datetimeFigureOut">
               <a:rPr lang="en-GB" smtClean="0"/>
-              <a:t>17/11/2025</a:t>
+              <a:t>03/12/2025</a:t>
             </a:fld>
             <a:endParaRPr lang="en-GB"/>
           </a:p>
@@ -2252,7 +2348,7 @@
           <a:p>
             <a:fld id="{9298EC9D-8325-4ACF-84B5-A03B1DD693C8}" type="datetimeFigureOut">
               <a:rPr lang="en-GB" smtClean="0"/>
-              <a:t>17/11/2025</a:t>
+              <a:t>03/12/2025</a:t>
             </a:fld>
             <a:endParaRPr lang="en-GB"/>
           </a:p>
@@ -2365,7 +2461,7 @@
           <a:p>
             <a:fld id="{9298EC9D-8325-4ACF-84B5-A03B1DD693C8}" type="datetimeFigureOut">
               <a:rPr lang="en-GB" smtClean="0"/>
-              <a:t>17/11/2025</a:t>
+              <a:t>03/12/2025</a:t>
             </a:fld>
             <a:endParaRPr lang="en-GB"/>
           </a:p>
@@ -2678,7 +2774,7 @@
           <a:p>
             <a:fld id="{9298EC9D-8325-4ACF-84B5-A03B1DD693C8}" type="datetimeFigureOut">
               <a:rPr lang="en-GB" smtClean="0"/>
-              <a:t>17/11/2025</a:t>
+              <a:t>03/12/2025</a:t>
             </a:fld>
             <a:endParaRPr lang="en-GB"/>
           </a:p>
@@ -2967,7 +3063,7 @@
           <a:p>
             <a:fld id="{9298EC9D-8325-4ACF-84B5-A03B1DD693C8}" type="datetimeFigureOut">
               <a:rPr lang="en-GB" smtClean="0"/>
-              <a:t>17/11/2025</a:t>
+              <a:t>03/12/2025</a:t>
             </a:fld>
             <a:endParaRPr lang="en-GB"/>
           </a:p>
@@ -3210,7 +3306,7 @@
           <a:p>
             <a:fld id="{9298EC9D-8325-4ACF-84B5-A03B1DD693C8}" type="datetimeFigureOut">
               <a:rPr lang="en-GB" smtClean="0"/>
-              <a:t>17/11/2025</a:t>
+              <a:t>03/12/2025</a:t>
             </a:fld>
             <a:endParaRPr lang="en-GB"/>
           </a:p>
@@ -3826,6 +3922,666 @@
 </p:sld>
 </file>
 
+<file path=ppt/slides/slide10.xml><?xml version="1.0" encoding="utf-8"?>
+<p:sld xmlns:a="http://schemas.openxmlformats.org/drawingml/2006/main" xmlns:r="http://schemas.openxmlformats.org/officeDocument/2006/relationships" xmlns:p="http://schemas.openxmlformats.org/presentationml/2006/main">
+  <p:cSld>
+    <p:spTree>
+      <p:nvGrpSpPr>
+        <p:cNvPr id="1" name=""/>
+        <p:cNvGrpSpPr/>
+        <p:nvPr/>
+      </p:nvGrpSpPr>
+      <p:grpSpPr>
+        <a:xfrm>
+          <a:off x="0" y="0"/>
+          <a:ext cx="0" cy="0"/>
+          <a:chOff x="0" y="0"/>
+          <a:chExt cx="0" cy="0"/>
+        </a:xfrm>
+      </p:grpSpPr>
+      <p:pic>
+        <p:nvPicPr>
+          <p:cNvPr id="5" name="Picture 4">
+            <a:extLst>
+              <a:ext uri="{FF2B5EF4-FFF2-40B4-BE49-F238E27FC236}">
+                <a16:creationId xmlns:a16="http://schemas.microsoft.com/office/drawing/2014/main" id="{271C4D88-962B-B27E-4096-68DA3C8A9F3A}"/>
+              </a:ext>
+            </a:extLst>
+          </p:cNvPr>
+          <p:cNvPicPr>
+            <a:picLocks noChangeAspect="1"/>
+          </p:cNvPicPr>
+          <p:nvPr/>
+        </p:nvPicPr>
+        <p:blipFill>
+          <a:blip r:embed="rId2"/>
+          <a:stretch>
+            <a:fillRect/>
+          </a:stretch>
+        </p:blipFill>
+        <p:spPr>
+          <a:xfrm>
+            <a:off x="965326" y="0"/>
+            <a:ext cx="10261347" cy="6858000"/>
+          </a:xfrm>
+          <a:prstGeom prst="rect">
+            <a:avLst/>
+          </a:prstGeom>
+        </p:spPr>
+      </p:pic>
+      <p:sp>
+        <p:nvSpPr>
+          <p:cNvPr id="6" name="Rectangle 5">
+            <a:extLst>
+              <a:ext uri="{FF2B5EF4-FFF2-40B4-BE49-F238E27FC236}">
+                <a16:creationId xmlns:a16="http://schemas.microsoft.com/office/drawing/2014/main" id="{AA6E6BF6-814D-9106-B9BE-A4AEE55FC0B3}"/>
+              </a:ext>
+            </a:extLst>
+          </p:cNvPr>
+          <p:cNvSpPr/>
+          <p:nvPr/>
+        </p:nvSpPr>
+        <p:spPr>
+          <a:xfrm>
+            <a:off x="7049991" y="290769"/>
+            <a:ext cx="4176681" cy="4181478"/>
+          </a:xfrm>
+          <a:prstGeom prst="rect">
+            <a:avLst/>
+          </a:prstGeom>
+          <a:noFill/>
+          <a:ln w="28575">
+            <a:solidFill>
+              <a:srgbClr val="C00000"/>
+            </a:solidFill>
+          </a:ln>
+        </p:spPr>
+        <p:style>
+          <a:lnRef idx="2">
+            <a:schemeClr val="accent1">
+              <a:shade val="15000"/>
+            </a:schemeClr>
+          </a:lnRef>
+          <a:fillRef idx="1">
+            <a:schemeClr val="accent1"/>
+          </a:fillRef>
+          <a:effectRef idx="0">
+            <a:schemeClr val="accent1"/>
+          </a:effectRef>
+          <a:fontRef idx="minor">
+            <a:schemeClr val="lt1"/>
+          </a:fontRef>
+        </p:style>
+        <p:txBody>
+          <a:bodyPr rtlCol="0" anchor="ctr"/>
+          <a:lstStyle/>
+          <a:p>
+            <a:pPr algn="ctr"/>
+            <a:endParaRPr lang="en-GB"/>
+          </a:p>
+        </p:txBody>
+      </p:sp>
+      <p:sp>
+        <p:nvSpPr>
+          <p:cNvPr id="7" name="Rectangle 6">
+            <a:extLst>
+              <a:ext uri="{FF2B5EF4-FFF2-40B4-BE49-F238E27FC236}">
+                <a16:creationId xmlns:a16="http://schemas.microsoft.com/office/drawing/2014/main" id="{A6A3AF9B-D373-62F3-A535-7484642FA39A}"/>
+              </a:ext>
+            </a:extLst>
+          </p:cNvPr>
+          <p:cNvSpPr/>
+          <p:nvPr/>
+        </p:nvSpPr>
+        <p:spPr>
+          <a:xfrm>
+            <a:off x="6384972" y="4472247"/>
+            <a:ext cx="539529" cy="266008"/>
+          </a:xfrm>
+          <a:prstGeom prst="rect">
+            <a:avLst/>
+          </a:prstGeom>
+          <a:noFill/>
+          <a:ln w="28575">
+            <a:solidFill>
+              <a:srgbClr val="C00000"/>
+            </a:solidFill>
+          </a:ln>
+        </p:spPr>
+        <p:style>
+          <a:lnRef idx="2">
+            <a:schemeClr val="accent1">
+              <a:shade val="15000"/>
+            </a:schemeClr>
+          </a:lnRef>
+          <a:fillRef idx="1">
+            <a:schemeClr val="accent1"/>
+          </a:fillRef>
+          <a:effectRef idx="0">
+            <a:schemeClr val="accent1"/>
+          </a:effectRef>
+          <a:fontRef idx="minor">
+            <a:schemeClr val="lt1"/>
+          </a:fontRef>
+        </p:style>
+        <p:txBody>
+          <a:bodyPr rtlCol="0" anchor="ctr"/>
+          <a:lstStyle/>
+          <a:p>
+            <a:pPr algn="ctr"/>
+            <a:endParaRPr lang="en-GB"/>
+          </a:p>
+        </p:txBody>
+      </p:sp>
+      <p:sp>
+        <p:nvSpPr>
+          <p:cNvPr id="8" name="Rectangle 7">
+            <a:extLst>
+              <a:ext uri="{FF2B5EF4-FFF2-40B4-BE49-F238E27FC236}">
+                <a16:creationId xmlns:a16="http://schemas.microsoft.com/office/drawing/2014/main" id="{5B1B194C-07D7-8055-2D16-0AC38959C0CF}"/>
+              </a:ext>
+            </a:extLst>
+          </p:cNvPr>
+          <p:cNvSpPr/>
+          <p:nvPr/>
+        </p:nvSpPr>
+        <p:spPr>
+          <a:xfrm>
+            <a:off x="3143009" y="5037336"/>
+            <a:ext cx="3781492" cy="1155646"/>
+          </a:xfrm>
+          <a:prstGeom prst="rect">
+            <a:avLst/>
+          </a:prstGeom>
+          <a:noFill/>
+          <a:ln w="28575">
+            <a:solidFill>
+              <a:srgbClr val="C00000"/>
+            </a:solidFill>
+          </a:ln>
+        </p:spPr>
+        <p:style>
+          <a:lnRef idx="2">
+            <a:schemeClr val="accent1">
+              <a:shade val="15000"/>
+            </a:schemeClr>
+          </a:lnRef>
+          <a:fillRef idx="1">
+            <a:schemeClr val="accent1"/>
+          </a:fillRef>
+          <a:effectRef idx="0">
+            <a:schemeClr val="accent1"/>
+          </a:effectRef>
+          <a:fontRef idx="minor">
+            <a:schemeClr val="lt1"/>
+          </a:fontRef>
+        </p:style>
+        <p:txBody>
+          <a:bodyPr rtlCol="0" anchor="ctr"/>
+          <a:lstStyle/>
+          <a:p>
+            <a:pPr algn="ctr"/>
+            <a:endParaRPr lang="en-GB"/>
+          </a:p>
+        </p:txBody>
+      </p:sp>
+      <p:sp>
+        <p:nvSpPr>
+          <p:cNvPr id="9" name="TextBox 8">
+            <a:extLst>
+              <a:ext uri="{FF2B5EF4-FFF2-40B4-BE49-F238E27FC236}">
+                <a16:creationId xmlns:a16="http://schemas.microsoft.com/office/drawing/2014/main" id="{085A1F90-4066-9569-1CE4-F8237598EEDD}"/>
+              </a:ext>
+            </a:extLst>
+          </p:cNvPr>
+          <p:cNvSpPr txBox="1"/>
+          <p:nvPr/>
+        </p:nvSpPr>
+        <p:spPr>
+          <a:xfrm>
+            <a:off x="7928358" y="2196842"/>
+            <a:ext cx="2419945" cy="369332"/>
+          </a:xfrm>
+          <a:prstGeom prst="rect">
+            <a:avLst/>
+          </a:prstGeom>
+          <a:noFill/>
+        </p:spPr>
+        <p:txBody>
+          <a:bodyPr wrap="square" rtlCol="0">
+            <a:spAutoFit/>
+          </a:bodyPr>
+          <a:lstStyle/>
+          <a:p>
+            <a:pPr algn="ctr"/>
+            <a:r>
+              <a:rPr lang="en-GB" dirty="0">
+                <a:solidFill>
+                  <a:srgbClr val="C00000"/>
+                </a:solidFill>
+              </a:rPr>
+              <a:t>Interactive session</a:t>
+            </a:r>
+          </a:p>
+        </p:txBody>
+      </p:sp>
+      <p:sp>
+        <p:nvSpPr>
+          <p:cNvPr id="10" name="TextBox 9">
+            <a:extLst>
+              <a:ext uri="{FF2B5EF4-FFF2-40B4-BE49-F238E27FC236}">
+                <a16:creationId xmlns:a16="http://schemas.microsoft.com/office/drawing/2014/main" id="{3CCA8B45-0E3C-D5BB-8032-33542ADBFF54}"/>
+              </a:ext>
+            </a:extLst>
+          </p:cNvPr>
+          <p:cNvSpPr txBox="1"/>
+          <p:nvPr/>
+        </p:nvSpPr>
+        <p:spPr>
+          <a:xfrm>
+            <a:off x="6718385" y="5823650"/>
+            <a:ext cx="2419945" cy="369332"/>
+          </a:xfrm>
+          <a:prstGeom prst="rect">
+            <a:avLst/>
+          </a:prstGeom>
+          <a:noFill/>
+        </p:spPr>
+        <p:txBody>
+          <a:bodyPr wrap="square" rtlCol="0">
+            <a:spAutoFit/>
+          </a:bodyPr>
+          <a:lstStyle/>
+          <a:p>
+            <a:pPr algn="ctr"/>
+            <a:r>
+              <a:rPr lang="en-GB" dirty="0">
+                <a:solidFill>
+                  <a:srgbClr val="C00000"/>
+                </a:solidFill>
+              </a:rPr>
+              <a:t>Variable explorer</a:t>
+            </a:r>
+          </a:p>
+        </p:txBody>
+      </p:sp>
+    </p:spTree>
+    <p:extLst>
+      <p:ext uri="{BB962C8B-B14F-4D97-AF65-F5344CB8AC3E}">
+        <p14:creationId xmlns:p14="http://schemas.microsoft.com/office/powerpoint/2010/main" val="3232102836"/>
+      </p:ext>
+    </p:extLst>
+  </p:cSld>
+  <p:clrMapOvr>
+    <a:masterClrMapping/>
+  </p:clrMapOvr>
+</p:sld>
+</file>
+
+<file path=ppt/slides/slide11.xml><?xml version="1.0" encoding="utf-8"?>
+<p:sld xmlns:a="http://schemas.openxmlformats.org/drawingml/2006/main" xmlns:r="http://schemas.openxmlformats.org/officeDocument/2006/relationships" xmlns:p="http://schemas.openxmlformats.org/presentationml/2006/main">
+  <p:cSld>
+    <p:spTree>
+      <p:nvGrpSpPr>
+        <p:cNvPr id="1" name=""/>
+        <p:cNvGrpSpPr/>
+        <p:nvPr/>
+      </p:nvGrpSpPr>
+      <p:grpSpPr>
+        <a:xfrm>
+          <a:off x="0" y="0"/>
+          <a:ext cx="0" cy="0"/>
+          <a:chOff x="0" y="0"/>
+          <a:chExt cx="0" cy="0"/>
+        </a:xfrm>
+      </p:grpSpPr>
+      <p:pic>
+        <p:nvPicPr>
+          <p:cNvPr id="5" name="Picture 4">
+            <a:extLst>
+              <a:ext uri="{FF2B5EF4-FFF2-40B4-BE49-F238E27FC236}">
+                <a16:creationId xmlns:a16="http://schemas.microsoft.com/office/drawing/2014/main" id="{F13740C8-6FE7-F756-4EF3-618A8393FC35}"/>
+              </a:ext>
+            </a:extLst>
+          </p:cNvPr>
+          <p:cNvPicPr>
+            <a:picLocks noChangeAspect="1"/>
+          </p:cNvPicPr>
+          <p:nvPr/>
+        </p:nvPicPr>
+        <p:blipFill>
+          <a:blip r:embed="rId2"/>
+          <a:stretch>
+            <a:fillRect/>
+          </a:stretch>
+        </p:blipFill>
+        <p:spPr>
+          <a:xfrm>
+            <a:off x="965326" y="0"/>
+            <a:ext cx="10261347" cy="6858000"/>
+          </a:xfrm>
+          <a:prstGeom prst="rect">
+            <a:avLst/>
+          </a:prstGeom>
+        </p:spPr>
+      </p:pic>
+      <p:sp>
+        <p:nvSpPr>
+          <p:cNvPr id="6" name="Rectangle 5">
+            <a:extLst>
+              <a:ext uri="{FF2B5EF4-FFF2-40B4-BE49-F238E27FC236}">
+                <a16:creationId xmlns:a16="http://schemas.microsoft.com/office/drawing/2014/main" id="{B4989424-24FC-F56C-B95A-B5978310E32B}"/>
+              </a:ext>
+            </a:extLst>
+          </p:cNvPr>
+          <p:cNvSpPr/>
+          <p:nvPr/>
+        </p:nvSpPr>
+        <p:spPr>
+          <a:xfrm>
+            <a:off x="3143008" y="4630189"/>
+            <a:ext cx="4404947" cy="1496291"/>
+          </a:xfrm>
+          <a:prstGeom prst="rect">
+            <a:avLst/>
+          </a:prstGeom>
+          <a:noFill/>
+          <a:ln w="28575">
+            <a:solidFill>
+              <a:srgbClr val="C00000"/>
+            </a:solidFill>
+          </a:ln>
+        </p:spPr>
+        <p:style>
+          <a:lnRef idx="2">
+            <a:schemeClr val="accent1">
+              <a:shade val="15000"/>
+            </a:schemeClr>
+          </a:lnRef>
+          <a:fillRef idx="1">
+            <a:schemeClr val="accent1"/>
+          </a:fillRef>
+          <a:effectRef idx="0">
+            <a:schemeClr val="accent1"/>
+          </a:effectRef>
+          <a:fontRef idx="minor">
+            <a:schemeClr val="lt1"/>
+          </a:fontRef>
+        </p:style>
+        <p:txBody>
+          <a:bodyPr rtlCol="0" anchor="ctr"/>
+          <a:lstStyle/>
+          <a:p>
+            <a:pPr algn="ctr"/>
+            <a:endParaRPr lang="en-GB"/>
+          </a:p>
+        </p:txBody>
+      </p:sp>
+    </p:spTree>
+    <p:extLst>
+      <p:ext uri="{BB962C8B-B14F-4D97-AF65-F5344CB8AC3E}">
+        <p14:creationId xmlns:p14="http://schemas.microsoft.com/office/powerpoint/2010/main" val="2446759160"/>
+      </p:ext>
+    </p:extLst>
+  </p:cSld>
+  <p:clrMapOvr>
+    <a:masterClrMapping/>
+  </p:clrMapOvr>
+</p:sld>
+</file>
+
+<file path=ppt/slides/slide12.xml><?xml version="1.0" encoding="utf-8"?>
+<p:sld xmlns:a="http://schemas.openxmlformats.org/drawingml/2006/main" xmlns:r="http://schemas.openxmlformats.org/officeDocument/2006/relationships" xmlns:p="http://schemas.openxmlformats.org/presentationml/2006/main">
+  <p:cSld>
+    <p:spTree>
+      <p:nvGrpSpPr>
+        <p:cNvPr id="1" name=""/>
+        <p:cNvGrpSpPr/>
+        <p:nvPr/>
+      </p:nvGrpSpPr>
+      <p:grpSpPr>
+        <a:xfrm>
+          <a:off x="0" y="0"/>
+          <a:ext cx="0" cy="0"/>
+          <a:chOff x="0" y="0"/>
+          <a:chExt cx="0" cy="0"/>
+        </a:xfrm>
+      </p:grpSpPr>
+      <p:pic>
+        <p:nvPicPr>
+          <p:cNvPr id="5" name="Picture 4">
+            <a:extLst>
+              <a:ext uri="{FF2B5EF4-FFF2-40B4-BE49-F238E27FC236}">
+                <a16:creationId xmlns:a16="http://schemas.microsoft.com/office/drawing/2014/main" id="{A296AC05-9F6B-FE78-D044-CF417F668B29}"/>
+              </a:ext>
+            </a:extLst>
+          </p:cNvPr>
+          <p:cNvPicPr>
+            <a:picLocks noChangeAspect="1"/>
+          </p:cNvPicPr>
+          <p:nvPr/>
+        </p:nvPicPr>
+        <p:blipFill>
+          <a:blip r:embed="rId2"/>
+          <a:stretch>
+            <a:fillRect/>
+          </a:stretch>
+        </p:blipFill>
+        <p:spPr>
+          <a:xfrm>
+            <a:off x="3041650" y="2292350"/>
+            <a:ext cx="6108700" cy="2273300"/>
+          </a:xfrm>
+          <a:prstGeom prst="rect">
+            <a:avLst/>
+          </a:prstGeom>
+        </p:spPr>
+      </p:pic>
+    </p:spTree>
+    <p:extLst>
+      <p:ext uri="{BB962C8B-B14F-4D97-AF65-F5344CB8AC3E}">
+        <p14:creationId xmlns:p14="http://schemas.microsoft.com/office/powerpoint/2010/main" val="389197133"/>
+      </p:ext>
+    </p:extLst>
+  </p:cSld>
+  <p:clrMapOvr>
+    <a:masterClrMapping/>
+  </p:clrMapOvr>
+</p:sld>
+</file>
+
+<file path=ppt/slides/slide13.xml><?xml version="1.0" encoding="utf-8"?>
+<p:sld xmlns:a="http://schemas.openxmlformats.org/drawingml/2006/main" xmlns:r="http://schemas.openxmlformats.org/officeDocument/2006/relationships" xmlns:p="http://schemas.openxmlformats.org/presentationml/2006/main">
+  <p:cSld>
+    <p:spTree>
+      <p:nvGrpSpPr>
+        <p:cNvPr id="1" name=""/>
+        <p:cNvGrpSpPr/>
+        <p:nvPr/>
+      </p:nvGrpSpPr>
+      <p:grpSpPr>
+        <a:xfrm>
+          <a:off x="0" y="0"/>
+          <a:ext cx="0" cy="0"/>
+          <a:chOff x="0" y="0"/>
+          <a:chExt cx="0" cy="0"/>
+        </a:xfrm>
+      </p:grpSpPr>
+      <p:pic>
+        <p:nvPicPr>
+          <p:cNvPr id="5" name="Picture 4">
+            <a:extLst>
+              <a:ext uri="{FF2B5EF4-FFF2-40B4-BE49-F238E27FC236}">
+                <a16:creationId xmlns:a16="http://schemas.microsoft.com/office/drawing/2014/main" id="{EE1CA0F7-D262-6C35-8DF7-458833251245}"/>
+              </a:ext>
+            </a:extLst>
+          </p:cNvPr>
+          <p:cNvPicPr>
+            <a:picLocks noChangeAspect="1"/>
+          </p:cNvPicPr>
+          <p:nvPr/>
+        </p:nvPicPr>
+        <p:blipFill>
+          <a:blip r:embed="rId2"/>
+          <a:stretch>
+            <a:fillRect/>
+          </a:stretch>
+        </p:blipFill>
+        <p:spPr>
+          <a:xfrm>
+            <a:off x="1135846" y="0"/>
+            <a:ext cx="9920307" cy="6858000"/>
+          </a:xfrm>
+          <a:prstGeom prst="rect">
+            <a:avLst/>
+          </a:prstGeom>
+        </p:spPr>
+      </p:pic>
+      <p:sp>
+        <p:nvSpPr>
+          <p:cNvPr id="6" name="Rectangle 5">
+            <a:extLst>
+              <a:ext uri="{FF2B5EF4-FFF2-40B4-BE49-F238E27FC236}">
+                <a16:creationId xmlns:a16="http://schemas.microsoft.com/office/drawing/2014/main" id="{FD7CE4DC-7CD7-55F1-4615-5C715840C5CC}"/>
+              </a:ext>
+            </a:extLst>
+          </p:cNvPr>
+          <p:cNvSpPr/>
+          <p:nvPr/>
+        </p:nvSpPr>
+        <p:spPr>
+          <a:xfrm>
+            <a:off x="2062956" y="3099563"/>
+            <a:ext cx="4225201" cy="2128420"/>
+          </a:xfrm>
+          <a:prstGeom prst="rect">
+            <a:avLst/>
+          </a:prstGeom>
+          <a:noFill/>
+          <a:ln w="28575">
+            <a:solidFill>
+              <a:srgbClr val="C00000"/>
+            </a:solidFill>
+          </a:ln>
+        </p:spPr>
+        <p:style>
+          <a:lnRef idx="2">
+            <a:schemeClr val="accent1">
+              <a:shade val="15000"/>
+            </a:schemeClr>
+          </a:lnRef>
+          <a:fillRef idx="1">
+            <a:schemeClr val="accent1"/>
+          </a:fillRef>
+          <a:effectRef idx="0">
+            <a:schemeClr val="accent1"/>
+          </a:effectRef>
+          <a:fontRef idx="minor">
+            <a:schemeClr val="lt1"/>
+          </a:fontRef>
+        </p:style>
+        <p:txBody>
+          <a:bodyPr rtlCol="0" anchor="ctr"/>
+          <a:lstStyle/>
+          <a:p>
+            <a:pPr algn="ctr"/>
+            <a:endParaRPr lang="en-GB"/>
+          </a:p>
+        </p:txBody>
+      </p:sp>
+    </p:spTree>
+    <p:extLst>
+      <p:ext uri="{BB962C8B-B14F-4D97-AF65-F5344CB8AC3E}">
+        <p14:creationId xmlns:p14="http://schemas.microsoft.com/office/powerpoint/2010/main" val="3419318905"/>
+      </p:ext>
+    </p:extLst>
+  </p:cSld>
+  <p:clrMapOvr>
+    <a:masterClrMapping/>
+  </p:clrMapOvr>
+</p:sld>
+</file>
+
+<file path=ppt/slides/slide14.xml><?xml version="1.0" encoding="utf-8"?>
+<p:sld xmlns:a="http://schemas.openxmlformats.org/drawingml/2006/main" xmlns:r="http://schemas.openxmlformats.org/officeDocument/2006/relationships" xmlns:p="http://schemas.openxmlformats.org/presentationml/2006/main">
+  <p:cSld>
+    <p:spTree>
+      <p:nvGrpSpPr>
+        <p:cNvPr id="1" name=""/>
+        <p:cNvGrpSpPr/>
+        <p:nvPr/>
+      </p:nvGrpSpPr>
+      <p:grpSpPr>
+        <a:xfrm>
+          <a:off x="0" y="0"/>
+          <a:ext cx="0" cy="0"/>
+          <a:chOff x="0" y="0"/>
+          <a:chExt cx="0" cy="0"/>
+        </a:xfrm>
+      </p:grpSpPr>
+      <p:sp>
+        <p:nvSpPr>
+          <p:cNvPr id="2" name="Title 1">
+            <a:extLst>
+              <a:ext uri="{FF2B5EF4-FFF2-40B4-BE49-F238E27FC236}">
+                <a16:creationId xmlns:a16="http://schemas.microsoft.com/office/drawing/2014/main" id="{8048B479-643E-4AEB-B584-223925D7DA94}"/>
+              </a:ext>
+            </a:extLst>
+          </p:cNvPr>
+          <p:cNvSpPr>
+            <a:spLocks noGrp="1"/>
+          </p:cNvSpPr>
+          <p:nvPr>
+            <p:ph type="title"/>
+          </p:nvPr>
+        </p:nvSpPr>
+        <p:spPr/>
+        <p:txBody>
+          <a:bodyPr/>
+          <a:lstStyle/>
+          <a:p>
+            <a:endParaRPr lang="en-GB"/>
+          </a:p>
+        </p:txBody>
+      </p:sp>
+      <p:sp>
+        <p:nvSpPr>
+          <p:cNvPr id="3" name="Content Placeholder 2">
+            <a:extLst>
+              <a:ext uri="{FF2B5EF4-FFF2-40B4-BE49-F238E27FC236}">
+                <a16:creationId xmlns:a16="http://schemas.microsoft.com/office/drawing/2014/main" id="{0A51269E-1C04-1545-ADEF-208D090C04C5}"/>
+              </a:ext>
+            </a:extLst>
+          </p:cNvPr>
+          <p:cNvSpPr>
+            <a:spLocks noGrp="1"/>
+          </p:cNvSpPr>
+          <p:nvPr>
+            <p:ph idx="1"/>
+          </p:nvPr>
+        </p:nvSpPr>
+        <p:spPr/>
+        <p:txBody>
+          <a:bodyPr/>
+          <a:lstStyle/>
+          <a:p>
+            <a:endParaRPr lang="en-GB"/>
+          </a:p>
+        </p:txBody>
+      </p:sp>
+    </p:spTree>
+    <p:extLst>
+      <p:ext uri="{BB962C8B-B14F-4D97-AF65-F5344CB8AC3E}">
+        <p14:creationId xmlns:p14="http://schemas.microsoft.com/office/powerpoint/2010/main" val="326291998"/>
+      </p:ext>
+    </p:extLst>
+  </p:cSld>
+  <p:clrMapOvr>
+    <a:masterClrMapping/>
+  </p:clrMapOvr>
+</p:sld>
+</file>
+
 <file path=ppt/slides/slide2.xml><?xml version="1.0" encoding="utf-8"?>
 <p:sld xmlns:a="http://schemas.openxmlformats.org/drawingml/2006/main" xmlns:r="http://schemas.openxmlformats.org/officeDocument/2006/relationships" xmlns:p="http://schemas.openxmlformats.org/presentationml/2006/main">
   <p:cSld>
@@ -4993,6 +5749,118 @@
     <p:extLst>
       <p:ext uri="{BB962C8B-B14F-4D97-AF65-F5344CB8AC3E}">
         <p14:creationId xmlns:p14="http://schemas.microsoft.com/office/powerpoint/2010/main" val="1347173010"/>
+      </p:ext>
+    </p:extLst>
+  </p:cSld>
+  <p:clrMapOvr>
+    <a:masterClrMapping/>
+  </p:clrMapOvr>
+</p:sld>
+</file>
+
+<file path=ppt/slides/slide9.xml><?xml version="1.0" encoding="utf-8"?>
+<p:sld xmlns:a="http://schemas.openxmlformats.org/drawingml/2006/main" xmlns:r="http://schemas.openxmlformats.org/officeDocument/2006/relationships" xmlns:p="http://schemas.openxmlformats.org/presentationml/2006/main">
+  <p:cSld>
+    <p:spTree>
+      <p:nvGrpSpPr>
+        <p:cNvPr id="1" name=""/>
+        <p:cNvGrpSpPr/>
+        <p:nvPr/>
+      </p:nvGrpSpPr>
+      <p:grpSpPr>
+        <a:xfrm>
+          <a:off x="0" y="0"/>
+          <a:ext cx="0" cy="0"/>
+          <a:chOff x="0" y="0"/>
+          <a:chExt cx="0" cy="0"/>
+        </a:xfrm>
+      </p:grpSpPr>
+      <p:pic>
+        <p:nvPicPr>
+          <p:cNvPr id="5" name="Picture 4">
+            <a:extLst>
+              <a:ext uri="{FF2B5EF4-FFF2-40B4-BE49-F238E27FC236}">
+                <a16:creationId xmlns:a16="http://schemas.microsoft.com/office/drawing/2014/main" id="{C3381357-ABC9-858B-A06D-A3FC472E53C4}"/>
+              </a:ext>
+            </a:extLst>
+          </p:cNvPr>
+          <p:cNvPicPr>
+            <a:picLocks noChangeAspect="1"/>
+          </p:cNvPicPr>
+          <p:nvPr/>
+        </p:nvPicPr>
+        <p:blipFill>
+          <a:blip r:embed="rId2"/>
+          <a:stretch>
+            <a:fillRect/>
+          </a:stretch>
+        </p:blipFill>
+        <p:spPr>
+          <a:xfrm>
+            <a:off x="965326" y="0"/>
+            <a:ext cx="10261347" cy="6858000"/>
+          </a:xfrm>
+          <a:prstGeom prst="rect">
+            <a:avLst/>
+          </a:prstGeom>
+        </p:spPr>
+      </p:pic>
+      <p:sp>
+        <p:nvSpPr>
+          <p:cNvPr id="6" name="Rectangle 5">
+            <a:extLst>
+              <a:ext uri="{FF2B5EF4-FFF2-40B4-BE49-F238E27FC236}">
+                <a16:creationId xmlns:a16="http://schemas.microsoft.com/office/drawing/2014/main" id="{EC86F9EB-B7C4-09F7-7912-824EB010CB3E}"/>
+              </a:ext>
+            </a:extLst>
+          </p:cNvPr>
+          <p:cNvSpPr/>
+          <p:nvPr/>
+        </p:nvSpPr>
+        <p:spPr>
+          <a:xfrm>
+            <a:off x="4489672" y="739656"/>
+            <a:ext cx="464714" cy="199682"/>
+          </a:xfrm>
+          <a:prstGeom prst="rect">
+            <a:avLst/>
+          </a:prstGeom>
+          <a:noFill/>
+          <a:ln w="28575">
+            <a:solidFill>
+              <a:srgbClr val="C00000"/>
+            </a:solidFill>
+          </a:ln>
+        </p:spPr>
+        <p:style>
+          <a:lnRef idx="2">
+            <a:schemeClr val="accent1">
+              <a:shade val="15000"/>
+            </a:schemeClr>
+          </a:lnRef>
+          <a:fillRef idx="1">
+            <a:schemeClr val="accent1"/>
+          </a:fillRef>
+          <a:effectRef idx="0">
+            <a:schemeClr val="accent1"/>
+          </a:effectRef>
+          <a:fontRef idx="minor">
+            <a:schemeClr val="lt1"/>
+          </a:fontRef>
+        </p:style>
+        <p:txBody>
+          <a:bodyPr rtlCol="0" anchor="ctr"/>
+          <a:lstStyle/>
+          <a:p>
+            <a:pPr algn="ctr"/>
+            <a:endParaRPr lang="en-GB"/>
+          </a:p>
+        </p:txBody>
+      </p:sp>
+    </p:spTree>
+    <p:extLst>
+      <p:ext uri="{BB962C8B-B14F-4D97-AF65-F5344CB8AC3E}">
+        <p14:creationId xmlns:p14="http://schemas.microsoft.com/office/powerpoint/2010/main" val="630378577"/>
       </p:ext>
     </p:extLst>
   </p:cSld>

</xml_diff>